<commit_message>
Interim baseline report and update
</commit_message>
<xml_diff>
--- a/Doc/Agent_opt.pptx
+++ b/Doc/Agent_opt.pptx
@@ -116,26 +116,26 @@
   <p:extLst>
     <p:ext uri="{521415D9-36F7-43E2-AB2F-B90AF26B5E84}">
       <p14:sectionLst xmlns:p14="http://schemas.microsoft.com/office/powerpoint/2010/main">
-        <p14:section name="Purpose" id="{fcea8ac7-e159-59df-6a92-59c7d6457879}">
+        <p14:section name="Purpose" id="{0f38b0b2-aabc-0a5e-b521-10204035a18e}">
           <p14:sldIdLst>
             <p14:sldId id="256"/>
             <p14:sldId id="257"/>
             <p14:sldId id="258"/>
           </p14:sldIdLst>
         </p14:section>
-        <p14:section name="Method" id="{8291a709-03b0-e9fe-5cca-76ce4d093d4a}">
+        <p14:section name="Method" id="{0f2eed75-6f4f-3b31-9fd3-7231e8663dbf}">
           <p14:sldIdLst>
             <p14:sldId id="259"/>
             <p14:sldId id="260"/>
           </p14:sldIdLst>
         </p14:section>
-        <p14:section name="Status" id="{81b20470-172b-24ae-af9a-a3ba9496cb4b}">
+        <p14:section name="Status" id="{73430d65-2277-bcb6-e4ac-d530ac0e9f76}">
           <p14:sldIdLst>
             <p14:sldId id="261"/>
             <p14:sldId id="262"/>
           </p14:sldIdLst>
         </p14:section>
-        <p14:section name="Next" id="{d0632446-1edd-321d-a473-88c0119cf8f5}">
+        <p14:section name="Next" id="{ba01265d-3d94-c75b-0565-91ef4b505124}">
           <p14:sldIdLst>
             <p14:sldId id="263"/>
             <p14:sldId id="264"/>
@@ -161,7 +161,7 @@
       <c:layout/>
       <c:barChart>
         <c:barDir val="bar"/>
-        <c:grouping val="clustered"/>
+        <c:grouping val="stacked"/>
         <c:varyColors val="0"/>
         <c:ser>
           <c:idx val="0"/>
@@ -172,7 +172,7 @@
               <c:strCache>
                 <c:ptCount val="1"/>
                 <c:pt idx="0">
-                  <c:v>Share of wall-clock time</c:v>
+                  <c:v>Model reads its instructions (prefill)</c:v>
                 </c:pt>
               </c:strCache>
             </c:strRef>
@@ -185,13 +185,586 @@
           </c:spPr>
           <c:invertIfNegative val="0"/>
           <c:dLbls>
-            <c:numFmt formatCode="0&quot;%&quot;" sourceLinked="0"/>
+            <c:numFmt formatCode="#,##0" sourceLinked="0"/>
             <c:txPr>
               <a:bodyPr/>
               <a:lstStyle/>
               <a:p>
                 <a:pPr>
-                  <a:defRPr b="1" i="0" strike="noStrike" sz="1400" u="none">
+                  <a:defRPr b="0" i="0" strike="noStrike" sz="1200" u="none">
+                    <a:solidFill>
+                      <a:srgbClr val="000000"/>
+                    </a:solidFill>
+                    <a:latin typeface="Arial"/>
+                  </a:defRPr>
+                </a:pPr>
+              </a:p>
+            </c:txPr>
+            <c:showLegendKey val="0"/>
+            <c:showVal val="0"/>
+            <c:showCatName val="0"/>
+            <c:showSerName val="0"/>
+            <c:showPercent val="0"/>
+            <c:showBubbleSize val="0"/>
+            <c:showLeaderLines val="0"/>
+          </c:dLbls>
+          <c:cat>
+            <c:multiLvlStrRef>
+              <c:f>Sheet1!$A$2:$A$12</c:f>
+              <c:multiLvlStrCache>
+                <c:ptCount val="11"/>
+                <c:lvl>
+                  <c:pt idx="0">
+                    <c:v>Long context</c:v>
+                  </c:pt>
+                  <c:pt idx="1">
+                    <c:v>Reasoning</c:v>
+                  </c:pt>
+                  <c:pt idx="2">
+                    <c:v>Bug fix</c:v>
+                  </c:pt>
+                  <c:pt idx="3">
+                    <c:v>Repo Q&amp;A</c:v>
+                  </c:pt>
+                  <c:pt idx="4">
+                    <c:v>Research</c:v>
+                  </c:pt>
+                  <c:pt idx="5">
+                    <c:v>Log triage</c:v>
+                  </c:pt>
+                  <c:pt idx="6">
+                    <c:v>Code review</c:v>
+                  </c:pt>
+                  <c:pt idx="7">
+                    <c:v>Refactor</c:v>
+                  </c:pt>
+                  <c:pt idx="8">
+                    <c:v>Email / calendar</c:v>
+                  </c:pt>
+                  <c:pt idx="9">
+                    <c:v>Code generation</c:v>
+                  </c:pt>
+                  <c:pt idx="10">
+                    <c:v>All tasks</c:v>
+                  </c:pt>
+                </c:lvl>
+              </c:multiLvlStrCache>
+            </c:multiLvlStrRef>
+          </c:cat>
+          <c:val>
+            <c:numRef>
+              <c:f>Sheet1!$B$2:$B$12</c:f>
+              <c:numCache>
+                <c:formatCode>General</c:formatCode>
+                <c:ptCount val="11"/>
+                <c:pt idx="0">
+                  <c:v>80.7</c:v>
+                </c:pt>
+                <c:pt idx="1">
+                  <c:v>79.8</c:v>
+                </c:pt>
+                <c:pt idx="2">
+                  <c:v>70</c:v>
+                </c:pt>
+                <c:pt idx="3">
+                  <c:v>68</c:v>
+                </c:pt>
+                <c:pt idx="4">
+                  <c:v>67.4</c:v>
+                </c:pt>
+                <c:pt idx="5">
+                  <c:v>65.3</c:v>
+                </c:pt>
+                <c:pt idx="6">
+                  <c:v>57</c:v>
+                </c:pt>
+                <c:pt idx="7">
+                  <c:v>53.9</c:v>
+                </c:pt>
+                <c:pt idx="8">
+                  <c:v>48.3</c:v>
+                </c:pt>
+                <c:pt idx="9">
+                  <c:v>36.6</c:v>
+                </c:pt>
+                <c:pt idx="10">
+                  <c:v>54</c:v>
+                </c:pt>
+              </c:numCache>
+            </c:numRef>
+          </c:val>
+        </c:ser>
+        <c:ser>
+          <c:idx val="1"/>
+          <c:order val="1"/>
+          <c:tx>
+            <c:strRef>
+              <c:f>Sheet1!$C$1</c:f>
+              <c:strCache>
+                <c:ptCount val="1"/>
+                <c:pt idx="0">
+                  <c:v>Model writes the answer (decode)</c:v>
+                </c:pt>
+              </c:strCache>
+            </c:strRef>
+          </c:tx>
+          <c:spPr>
+            <a:solidFill>
+              <a:srgbClr val="2FA8A0"/>
+            </a:solidFill>
+            <a:effectLst/>
+          </c:spPr>
+          <c:invertIfNegative val="0"/>
+          <c:dLbls>
+            <c:numFmt formatCode="#,##0" sourceLinked="0"/>
+            <c:txPr>
+              <a:bodyPr/>
+              <a:lstStyle/>
+              <a:p>
+                <a:pPr>
+                  <a:defRPr b="0" i="0" strike="noStrike" sz="1200" u="none">
+                    <a:solidFill>
+                      <a:srgbClr val="000000"/>
+                    </a:solidFill>
+                    <a:latin typeface="Arial"/>
+                  </a:defRPr>
+                </a:pPr>
+              </a:p>
+            </c:txPr>
+            <c:showLegendKey val="0"/>
+            <c:showVal val="0"/>
+            <c:showCatName val="0"/>
+            <c:showSerName val="0"/>
+            <c:showPercent val="0"/>
+            <c:showBubbleSize val="0"/>
+            <c:showLeaderLines val="0"/>
+          </c:dLbls>
+          <c:cat>
+            <c:multiLvlStrRef>
+              <c:f>Sheet1!$A$2:$A$12</c:f>
+              <c:multiLvlStrCache>
+                <c:ptCount val="11"/>
+                <c:lvl>
+                  <c:pt idx="0">
+                    <c:v>Long context</c:v>
+                  </c:pt>
+                  <c:pt idx="1">
+                    <c:v>Reasoning</c:v>
+                  </c:pt>
+                  <c:pt idx="2">
+                    <c:v>Bug fix</c:v>
+                  </c:pt>
+                  <c:pt idx="3">
+                    <c:v>Repo Q&amp;A</c:v>
+                  </c:pt>
+                  <c:pt idx="4">
+                    <c:v>Research</c:v>
+                  </c:pt>
+                  <c:pt idx="5">
+                    <c:v>Log triage</c:v>
+                  </c:pt>
+                  <c:pt idx="6">
+                    <c:v>Code review</c:v>
+                  </c:pt>
+                  <c:pt idx="7">
+                    <c:v>Refactor</c:v>
+                  </c:pt>
+                  <c:pt idx="8">
+                    <c:v>Email / calendar</c:v>
+                  </c:pt>
+                  <c:pt idx="9">
+                    <c:v>Code generation</c:v>
+                  </c:pt>
+                  <c:pt idx="10">
+                    <c:v>All tasks</c:v>
+                  </c:pt>
+                </c:lvl>
+              </c:multiLvlStrCache>
+            </c:multiLvlStrRef>
+          </c:cat>
+          <c:val>
+            <c:numRef>
+              <c:f>Sheet1!$C$2:$C$12</c:f>
+              <c:numCache>
+                <c:formatCode>General</c:formatCode>
+                <c:ptCount val="11"/>
+                <c:pt idx="0">
+                  <c:v>17.3</c:v>
+                </c:pt>
+                <c:pt idx="1">
+                  <c:v>16.4</c:v>
+                </c:pt>
+                <c:pt idx="2">
+                  <c:v>27.2</c:v>
+                </c:pt>
+                <c:pt idx="3">
+                  <c:v>29.2</c:v>
+                </c:pt>
+                <c:pt idx="4">
+                  <c:v>30.1</c:v>
+                </c:pt>
+                <c:pt idx="5">
+                  <c:v>33.2</c:v>
+                </c:pt>
+                <c:pt idx="6">
+                  <c:v>40.4</c:v>
+                </c:pt>
+                <c:pt idx="7">
+                  <c:v>44.1</c:v>
+                </c:pt>
+                <c:pt idx="8">
+                  <c:v>39.9</c:v>
+                </c:pt>
+                <c:pt idx="9">
+                  <c:v>60.3</c:v>
+                </c:pt>
+                <c:pt idx="10">
+                  <c:v>42.7</c:v>
+                </c:pt>
+              </c:numCache>
+            </c:numRef>
+          </c:val>
+        </c:ser>
+        <c:ser>
+          <c:idx val="2"/>
+          <c:order val="2"/>
+          <c:tx>
+            <c:strRef>
+              <c:f>Sheet1!$D$1</c:f>
+              <c:strCache>
+                <c:ptCount val="1"/>
+                <c:pt idx="0">
+                  <c:v>Tools and overhead</c:v>
+                </c:pt>
+              </c:strCache>
+            </c:strRef>
+          </c:tx>
+          <c:spPr>
+            <a:solidFill>
+              <a:srgbClr val="B4BEC6"/>
+            </a:solidFill>
+            <a:effectLst/>
+          </c:spPr>
+          <c:invertIfNegative val="0"/>
+          <c:dLbls>
+            <c:numFmt formatCode="#,##0" sourceLinked="0"/>
+            <c:txPr>
+              <a:bodyPr/>
+              <a:lstStyle/>
+              <a:p>
+                <a:pPr>
+                  <a:defRPr b="0" i="0" strike="noStrike" sz="1200" u="none">
+                    <a:solidFill>
+                      <a:srgbClr val="000000"/>
+                    </a:solidFill>
+                    <a:latin typeface="Arial"/>
+                  </a:defRPr>
+                </a:pPr>
+              </a:p>
+            </c:txPr>
+            <c:showLegendKey val="0"/>
+            <c:showVal val="0"/>
+            <c:showCatName val="0"/>
+            <c:showSerName val="0"/>
+            <c:showPercent val="0"/>
+            <c:showBubbleSize val="0"/>
+            <c:showLeaderLines val="0"/>
+          </c:dLbls>
+          <c:cat>
+            <c:multiLvlStrRef>
+              <c:f>Sheet1!$A$2:$A$12</c:f>
+              <c:multiLvlStrCache>
+                <c:ptCount val="11"/>
+                <c:lvl>
+                  <c:pt idx="0">
+                    <c:v>Long context</c:v>
+                  </c:pt>
+                  <c:pt idx="1">
+                    <c:v>Reasoning</c:v>
+                  </c:pt>
+                  <c:pt idx="2">
+                    <c:v>Bug fix</c:v>
+                  </c:pt>
+                  <c:pt idx="3">
+                    <c:v>Repo Q&amp;A</c:v>
+                  </c:pt>
+                  <c:pt idx="4">
+                    <c:v>Research</c:v>
+                  </c:pt>
+                  <c:pt idx="5">
+                    <c:v>Log triage</c:v>
+                  </c:pt>
+                  <c:pt idx="6">
+                    <c:v>Code review</c:v>
+                  </c:pt>
+                  <c:pt idx="7">
+                    <c:v>Refactor</c:v>
+                  </c:pt>
+                  <c:pt idx="8">
+                    <c:v>Email / calendar</c:v>
+                  </c:pt>
+                  <c:pt idx="9">
+                    <c:v>Code generation</c:v>
+                  </c:pt>
+                  <c:pt idx="10">
+                    <c:v>All tasks</c:v>
+                  </c:pt>
+                </c:lvl>
+              </c:multiLvlStrCache>
+            </c:multiLvlStrRef>
+          </c:cat>
+          <c:val>
+            <c:numRef>
+              <c:f>Sheet1!$D$2:$D$12</c:f>
+              <c:numCache>
+                <c:formatCode>General</c:formatCode>
+                <c:ptCount val="11"/>
+                <c:pt idx="0">
+                  <c:v>1.9</c:v>
+                </c:pt>
+                <c:pt idx="1">
+                  <c:v>3.8</c:v>
+                </c:pt>
+                <c:pt idx="2">
+                  <c:v>2.8</c:v>
+                </c:pt>
+                <c:pt idx="3">
+                  <c:v>2.8</c:v>
+                </c:pt>
+                <c:pt idx="4">
+                  <c:v>2.4</c:v>
+                </c:pt>
+                <c:pt idx="5">
+                  <c:v>1.5</c:v>
+                </c:pt>
+                <c:pt idx="6">
+                  <c:v>2.5</c:v>
+                </c:pt>
+                <c:pt idx="7">
+                  <c:v>2</c:v>
+                </c:pt>
+                <c:pt idx="8">
+                  <c:v>11.8</c:v>
+                </c:pt>
+                <c:pt idx="9">
+                  <c:v>3</c:v>
+                </c:pt>
+                <c:pt idx="10">
+                  <c:v>3.3</c:v>
+                </c:pt>
+              </c:numCache>
+            </c:numRef>
+          </c:val>
+        </c:ser>
+        <c:dLbls>
+          <c:numFmt formatCode="#,##0" sourceLinked="0"/>
+          <c:txPr>
+            <a:bodyPr/>
+            <a:lstStyle/>
+            <a:p>
+              <a:pPr>
+                <a:defRPr b="0" i="0" strike="noStrike" sz="1200" u="none">
+                  <a:solidFill>
+                    <a:srgbClr val="000000"/>
+                  </a:solidFill>
+                  <a:latin typeface="Arial"/>
+                </a:defRPr>
+              </a:pPr>
+            </a:p>
+          </c:txPr>
+          <c:showLegendKey val="0"/>
+          <c:showVal val="0"/>
+          <c:showCatName val="0"/>
+          <c:showSerName val="0"/>
+          <c:showPercent val="0"/>
+          <c:showBubbleSize val="0"/>
+          <c:showLeaderLines val="0"/>
+        </c:dLbls>
+        <c:gapWidth val="40"/>
+        <c:overlap val="100"/>
+        <c:axId val="2094734554"/>
+        <c:axId val="2094734552"/>
+        <c:axId val="2094734556"/>
+      </c:barChart>
+      <c:catAx>
+        <c:axId val="2094734554"/>
+        <c:scaling>
+          <c:orientation val="maxMin"/>
+        </c:scaling>
+        <c:delete val="0"/>
+        <c:axPos val="l"/>
+        <c:numFmt formatCode="General" sourceLinked="1"/>
+        <c:majorTickMark val="out"/>
+        <c:minorTickMark val="none"/>
+        <c:tickLblPos val="nextTo"/>
+        <c:spPr>
+          <a:ln w="12700" cap="flat">
+            <a:solidFill>
+              <a:srgbClr val="888888"/>
+            </a:solidFill>
+            <a:prstDash val="solid"/>
+            <a:round/>
+          </a:ln>
+        </c:spPr>
+        <c:txPr>
+          <a:bodyPr/>
+          <a:lstStyle/>
+          <a:p>
+            <a:pPr>
+              <a:defRPr sz="1100" b="0" i="0" u="none" strike="noStrike">
+                <a:solidFill>
+                  <a:srgbClr val="1B262C"/>
+                </a:solidFill>
+                <a:latin typeface="+mn-lt"/>
+              </a:defRPr>
+            </a:pPr>
+            <a:endParaRPr lang="en-US"/>
+          </a:p>
+        </c:txPr>
+        <c:crossAx val="2094734552"/>
+        <c:crosses val="autoZero"/>
+        <c:auto val="1"/>
+        <c:lblAlgn val="ctr"/>
+        <c:noMultiLvlLbl val="1"/>
+      </c:catAx>
+      <c:valAx>
+        <c:axId val="2094734552"/>
+        <c:scaling>
+          <c:orientation val="minMax"/>
+          <c:max val="100"/>
+          <c:min val="0"/>
+        </c:scaling>
+        <c:delete val="0"/>
+        <c:axPos val="b"/>
+        <c:majorGridlines>
+          <c:spPr>
+            <a:ln w="9525" cap="flat">
+              <a:solidFill>
+                <a:srgbClr val="E1E6E8"/>
+              </a:solidFill>
+              <a:prstDash val="solid"/>
+              <a:round/>
+            </a:ln>
+          </c:spPr>
+        </c:majorGridlines>
+        <c:numFmt formatCode="0&quot;%&quot;" sourceLinked="0"/>
+        <c:majorTickMark val="out"/>
+        <c:minorTickMark val="none"/>
+        <c:tickLblPos val="low"/>
+        <c:spPr>
+          <a:ln w="12700" cap="flat">
+            <a:solidFill>
+              <a:srgbClr val="888888"/>
+            </a:solidFill>
+            <a:prstDash val="solid"/>
+            <a:round/>
+          </a:ln>
+        </c:spPr>
+        <c:txPr>
+          <a:bodyPr/>
+          <a:lstStyle/>
+          <a:p>
+            <a:pPr>
+              <a:defRPr sz="1100" b="0" i="0" u="none" strike="noStrike">
+                <a:solidFill>
+                  <a:srgbClr val="6C7A89"/>
+                </a:solidFill>
+                <a:latin typeface="+mn-lt"/>
+              </a:defRPr>
+            </a:pPr>
+            <a:endParaRPr lang="en-US"/>
+          </a:p>
+        </c:txPr>
+        <c:crossAx val="2094734554"/>
+        <c:crosses val="autoZero"/>
+        <c:crossBetween val="between"/>
+        <c:majorUnit val="25"/>
+      </c:valAx>
+      <c:spPr>
+        <a:noFill/>
+        <a:ln>
+          <a:noFill/>
+        </a:ln>
+        <a:effectLst/>
+      </c:spPr>
+    </c:plotArea>
+    <c:legend>
+      <c:legendPos val="b"/>
+      <c:overlay val="0"/>
+      <c:txPr>
+        <a:bodyPr/>
+        <a:lstStyle/>
+        <a:p>
+          <a:pPr>
+            <a:defRPr sz="1100">
+              <a:solidFill>
+                <a:srgbClr val="1B262C"/>
+              </a:solidFill>
+              <a:latin typeface="+mn-lt"/>
+              <a:cs typeface="+mn-lt"/>
+            </a:defRPr>
+          </a:pPr>
+          <a:endParaRPr lang="en-US"/>
+        </a:p>
+      </c:txPr>
+    </c:legend>
+    <c:plotVisOnly val="1"/>
+    <c:dispBlanksAs val="span"/>
+  </c:chart>
+  <c:spPr>
+    <a:noFill/>
+    <a:ln>
+      <a:noFill/>
+    </a:ln>
+    <a:effectLst/>
+  </c:spPr>
+  <c:externalData r:id="rId1">
+    <c:autoUpdate val="0"/>
+  </c:externalData>
+</c:chartSpace>
+</file>
+
+<file path=ppt/charts/chart2.xml><?xml version="1.0" encoding="utf-8"?>
+<c:chartSpace xmlns:c="http://schemas.openxmlformats.org/drawingml/2006/chart" xmlns:a="http://schemas.openxmlformats.org/drawingml/2006/main" xmlns:r="http://schemas.openxmlformats.org/officeDocument/2006/relationships">
+  <c:date1904 val="0"/>
+  <c:roundedCorners val="1"/>
+  <c:chart>
+    <c:autoTitleDeleted val="1"/>
+    <c:plotArea>
+      <c:layout/>
+      <c:barChart>
+        <c:barDir val="bar"/>
+        <c:grouping val="clustered"/>
+        <c:varyColors val="0"/>
+        <c:ser>
+          <c:idx val="0"/>
+          <c:order val="0"/>
+          <c:tx>
+            <c:strRef>
+              <c:f>Sheet1!$B$1</c:f>
+              <c:strCache>
+                <c:ptCount val="1"/>
+                <c:pt idx="0">
+                  <c:v>Runs passed (of 10)</c:v>
+                </c:pt>
+              </c:strCache>
+            </c:strRef>
+          </c:tx>
+          <c:spPr>
+            <a:solidFill>
+              <a:srgbClr val="3B6978"/>
+            </a:solidFill>
+            <a:effectLst/>
+          </c:spPr>
+          <c:invertIfNegative val="0"/>
+          <c:dLbls>
+            <c:numFmt formatCode="0" sourceLinked="0"/>
+            <c:txPr>
+              <a:bodyPr/>
+              <a:lstStyle/>
+              <a:p>
+                <a:pPr>
+                  <a:defRPr b="1" i="0" strike="noStrike" sz="1100" u="none">
                     <a:solidFill>
                       <a:srgbClr val="1B262C"/>
                     </a:solidFill>
@@ -208,53 +781,53 @@
             <c:showBubbleSize val="0"/>
             <c:showLeaderLines val="0"/>
           </c:dLbls>
-          <c:dPt>
-            <c:idx val="0"/>
-            <c:invertIfNegative val="0"/>
-            <c:bubble3D val="0"/>
-            <c:spPr>
-              <a:solidFill>
-                <a:srgbClr val="F2A33A"/>
-              </a:solidFill>
-              <a:effectLst/>
-            </c:spPr>
-          </c:dPt>
-          <c:dPt>
-            <c:idx val="1"/>
-            <c:invertIfNegative val="0"/>
-            <c:bubble3D val="0"/>
-            <c:spPr>
-              <a:solidFill>
-                <a:srgbClr val="2FA8A0"/>
-              </a:solidFill>
-              <a:effectLst/>
-            </c:spPr>
-          </c:dPt>
-          <c:dPt>
-            <c:idx val="2"/>
-            <c:invertIfNegative val="0"/>
-            <c:bubble3D val="0"/>
-            <c:spPr>
-              <a:solidFill>
-                <a:srgbClr val="B4BEC6"/>
-              </a:solidFill>
-              <a:effectLst/>
-            </c:spPr>
-          </c:dPt>
           <c:cat>
             <c:multiLvlStrRef>
-              <c:f>Sheet1!$A$2:$A$4</c:f>
+              <c:f>Sheet1!$A$2:$A$15</c:f>
               <c:multiLvlStrCache>
-                <c:ptCount val="3"/>
+                <c:ptCount val="14"/>
                 <c:lvl>
                   <c:pt idx="0">
-                    <c:v>Model reads its instructions (prefill)</c:v>
+                    <c:v>Dir stats (code gen)</c:v>
                   </c:pt>
                   <c:pt idx="1">
-                    <c:v>Model writes the answer (decode)</c:v>
+                    <c:v>Scientific (reasoning)</c:v>
                   </c:pt>
                   <c:pt idx="2">
-                    <c:v>Tools and overhead</c:v>
+                    <c:v>Confirm send (comms)</c:v>
+                  </c:pt>
+                  <c:pt idx="3">
+                    <c:v>Tidal report (long ctx)</c:v>
+                  </c:pt>
+                  <c:pt idx="4">
+                    <c:v>Rename (refactor)</c:v>
+                  </c:pt>
+                  <c:pt idx="5">
+                    <c:v>Moving average (bugfix)</c:v>
+                  </c:pt>
+                  <c:pt idx="6">
+                    <c:v>FizzBuzz (code gen)</c:v>
+                  </c:pt>
+                  <c:pt idx="7">
+                    <c:v>Compression (code gen)</c:v>
+                  </c:pt>
+                  <c:pt idx="8">
+                    <c:v>Pool exhaustion (logs)</c:v>
+                  </c:pt>
+                  <c:pt idx="9">
+                    <c:v>Retry policy (repo Q&amp;A)</c:v>
+                  </c:pt>
+                  <c:pt idx="10">
+                    <c:v>Ring buffer (code gen)</c:v>
+                  </c:pt>
+                  <c:pt idx="11">
+                    <c:v>sqrt (code review)</c:v>
+                  </c:pt>
+                  <c:pt idx="12">
+                    <c:v>Tax rates (reasoning)</c:v>
+                  </c:pt>
+                  <c:pt idx="13">
+                    <c:v>Free will (research)</c:v>
                   </c:pt>
                 </c:lvl>
               </c:multiLvlStrCache>
@@ -262,31 +835,64 @@
           </c:cat>
           <c:val>
             <c:numRef>
-              <c:f>Sheet1!$B$2:$B$4</c:f>
+              <c:f>Sheet1!$B$2:$B$15</c:f>
               <c:numCache>
                 <c:formatCode>General</c:formatCode>
-                <c:ptCount val="3"/>
+                <c:ptCount val="14"/>
                 <c:pt idx="0">
-                  <c:v>74.8</c:v>
+                  <c:v>10</c:v>
                 </c:pt>
                 <c:pt idx="1">
-                  <c:v>22.6</c:v>
+                  <c:v>10</c:v>
                 </c:pt>
                 <c:pt idx="2">
-                  <c:v>2.6</c:v>
+                  <c:v>10</c:v>
+                </c:pt>
+                <c:pt idx="3">
+                  <c:v>10</c:v>
+                </c:pt>
+                <c:pt idx="4">
+                  <c:v>9</c:v>
+                </c:pt>
+                <c:pt idx="5">
+                  <c:v>8</c:v>
+                </c:pt>
+                <c:pt idx="6">
+                  <c:v>8</c:v>
+                </c:pt>
+                <c:pt idx="7">
+                  <c:v>8</c:v>
+                </c:pt>
+                <c:pt idx="8">
+                  <c:v>8</c:v>
+                </c:pt>
+                <c:pt idx="9">
+                  <c:v>7</c:v>
+                </c:pt>
+                <c:pt idx="10">
+                  <c:v>6</c:v>
+                </c:pt>
+                <c:pt idx="11">
+                  <c:v>6</c:v>
+                </c:pt>
+                <c:pt idx="12">
+                  <c:v>3</c:v>
+                </c:pt>
+                <c:pt idx="13">
+                  <c:v>1</c:v>
                 </c:pt>
               </c:numCache>
             </c:numRef>
           </c:val>
         </c:ser>
         <c:dLbls>
-          <c:numFmt formatCode="0&quot;%&quot;" sourceLinked="0"/>
+          <c:numFmt formatCode="0" sourceLinked="0"/>
           <c:txPr>
             <a:bodyPr/>
             <a:lstStyle/>
             <a:p>
               <a:pPr>
-                <a:defRPr b="1" i="0" strike="noStrike" sz="1400" u="none">
+                <a:defRPr b="1" i="0" strike="noStrike" sz="1100" u="none">
                   <a:solidFill>
                     <a:srgbClr val="1B262C"/>
                   </a:solidFill>
@@ -303,7 +909,7 @@
           <c:showBubbleSize val="0"/>
           <c:showLeaderLines val="0"/>
         </c:dLbls>
-        <c:gapWidth val="55"/>
+        <c:gapWidth val="35"/>
         <c:overlap val="0"/>
         <c:axId val="2094734554"/>
         <c:axId val="2094734552"/>
@@ -334,7 +940,7 @@
           <a:lstStyle/>
           <a:p>
             <a:pPr>
-              <a:defRPr sz="1400" b="0" i="0" u="none" strike="noStrike">
+              <a:defRPr sz="1100" b="0" i="0" u="none" strike="noStrike">
                 <a:solidFill>
                   <a:srgbClr val="1B262C"/>
                 </a:solidFill>
@@ -354,7 +960,7 @@
         <c:axId val="2094734552"/>
         <c:scaling>
           <c:orientation val="minMax"/>
-          <c:max val="100"/>
+          <c:max val="11"/>
           <c:min val="0"/>
         </c:scaling>
         <c:delete val="1"/>
@@ -810,7 +1416,7 @@
           <a:p>
             <a:r>
               <a:rPr lang="en-US" dirty="0"/>
-              <a:t>Agent_opt is a measurement project: it studies how a locally hosted AI coding agent behaves on a single mid-range graphics card (RTX 3080, 10 GB). The first four milestones built the measuring tools; the next four use them. This deck explains why, how, where we are and what we need from you.</a:t>
+              <a:t>Agent_opt is a measurement project: it studies how a locally hosted AI coding agent behaves on a single mid-range graphics card (RTX 3080, 10 GB). The first four milestones built the measuring tools; the first full measurement run (168 runs) is done; the next steps use the tools for experiments. This deck explains why, how, where we are and what we need from you.</a:t>
             </a:r>
             <a:endParaRPr lang="en-US" dirty="0"/>
           </a:p>
@@ -1250,7 +1856,7 @@
           <a:p>
             <a:r>
               <a:rPr lang="en-US" dirty="0"/>
-              <a:t>This is the quality story for a manager: the numbers will be reproducible and statistically defensible. One example of why it matters: in an early check, two tasks that passed in single runs actually pass only about 40 percent of the time.</a:t>
+              <a:t>This is the quality story for a manager: the numbers will be reproducible and statistically defensible. One example of why it matters: in an early check, two tasks that passed in single runs actually pass only about 40 percent of the time. The full baseline confirmed it: only 4 of 14 tasks passed every time in 10 runs.</a:t>
             </a:r>
             <a:endParaRPr lang="en-US" dirty="0"/>
           </a:p>
@@ -1338,7 +1944,7 @@
           <a:p>
             <a:r>
               <a:rPr lang="en-US" dirty="0"/>
-              <a:t>Eight milestones in total. The first four built and verified the measuring equipment; that part is finished and tested. From M4 on we actually collect the data that answers the project question.</a:t>
+              <a:t>Eight milestones in total. The first four built and verified the measuring equipment; that part is finished and tested. The first full run (M4.1) is complete; the next steps compare settings against it.</a:t>
             </a:r>
             <a:endParaRPr lang="en-US" dirty="0"/>
           </a:p>
@@ -1426,7 +2032,7 @@
           <a:p>
             <a:r>
               <a:rPr lang="en-US" dirty="0"/>
-              <a:t>Early, small-sample observations that already change what we would try first: trimming the instructions the agent re-reads is likely to matter more than making answer generation faster. Tool steps are negligible. These are indications from two recorded runs and from the earlier parity pilot; the baseline run will confirm or correct them.</a:t>
+              <a:t>Source: the baseline run, 14 tasks x 10 runs at the 32k setting, 140 measured runs. Left: share of wall-clock time; the model's reading of its instructions (prefill) dominates for long-context and reasoning tasks, writing the answer dominates for code generation. Right: runs passed per task; with 10 runs each, only the extremes are clearly different (the research task needs a larger memory window and passed 1 of 10). The earlier two-run pilot suggested 75 percent prefill; the full run shows 54 percent overall, so that early figure applied only to short read-heavy tasks. Instrumentation overhead check is still inconclusive.</a:t>
             </a:r>
             <a:endParaRPr lang="en-US" dirty="0"/>
           </a:p>
@@ -2322,7 +2928,7 @@
                 <a:ea typeface="Calibri" pitchFamily="34" charset="-122"/>
                 <a:cs typeface="Calibri" pitchFamily="34" charset="-120"/>
               </a:rPr>
-              <a:t>Project overview for project management. Status: tooling built (M0 to M3), measurement campaign starting (M4).</a:t>
+              <a:t>Project overview for project management. Status: tooling built (M0 to M3), first full baseline measured (M4.1).</a:t>
             </a:r>
             <a:endParaRPr lang="en-US" sz="1600" dirty="0"/>
           </a:p>
@@ -2461,7 +3067,7 @@
                 <a:ea typeface="Cambria" pitchFamily="34" charset="-122"/>
                 <a:cs typeface="Cambria" pitchFamily="34" charset="-120"/>
               </a:rPr>
-              <a:t>277</a:t>
+              <a:t>279</a:t>
             </a:r>
             <a:endParaRPr lang="en-US" sz="4400" dirty="0"/>
           </a:p>
@@ -2539,7 +3145,7 @@
                 <a:ea typeface="Cambria" pitchFamily="34" charset="-122"/>
                 <a:cs typeface="Cambria" pitchFamily="34" charset="-120"/>
               </a:rPr>
-              <a:t>4 of 8</a:t>
+              <a:t>168</a:t>
             </a:r>
             <a:endParaRPr lang="en-US" sz="4400" dirty="0"/>
           </a:p>
@@ -2578,7 +3184,7 @@
                 <a:ea typeface="Calibri" pitchFamily="34" charset="-122"/>
                 <a:cs typeface="Calibri" pitchFamily="34" charset="-120"/>
               </a:rPr>
-              <a:t>milestones complete</a:t>
+              <a:t>baseline runs measured, no tooling failures</a:t>
             </a:r>
             <a:endParaRPr lang="en-US" sz="1400" dirty="0"/>
           </a:p>
@@ -2827,7 +3433,7 @@
                 <a:ea typeface="Calibri" pitchFamily="34" charset="-122"/>
                 <a:cs typeface="Calibri" pitchFamily="34" charset="-120"/>
               </a:rPr>
-              <a:t>10 repeats take about 6 hours per setup; the full sweep is about 35 to 40 hours of GPU time.</a:t>
+              <a:t>10 repeats took 5.5 hours for one setup; the full sweep is about 35 to 40 hours of GPU time.</a:t>
             </a:r>
             <a:endParaRPr lang="en-US" sz="1400" dirty="0"/>
           </a:p>
@@ -2971,7 +3577,7 @@
                 <a:ea typeface="Calibri" pitchFamily="34" charset="-122"/>
                 <a:cs typeface="Calibri" pitchFamily="34" charset="-120"/>
               </a:rPr>
-              <a:t>Most tasks pass, so differences can hide; some tasks may need to be made harder.</a:t>
+              <a:t>Four of 14 tasks pass every time, so they cannot show an improvement; some may need to be made harder.</a:t>
             </a:r>
             <a:endParaRPr lang="en-US" sz="1400" dirty="0"/>
           </a:p>
@@ -3631,7 +4237,7 @@
                 <a:ea typeface="Calibri" pitchFamily="34" charset="-122"/>
                 <a:cs typeface="Calibri" pitchFamily="34" charset="-120"/>
               </a:rPr>
-              <a:t>It needs a larger memory window than the baseline: keep it as a special case?</a:t>
+              <a:t>It passed only 1 of 10 runs at the baseline memory window and needs a larger one: keep it as a special case?</a:t>
             </a:r>
             <a:endParaRPr lang="en-US" sz="1400" dirty="0"/>
           </a:p>
@@ -6760,7 +7366,7 @@
                 <a:ea typeface="Calibri" pitchFamily="34" charset="-122"/>
                 <a:cs typeface="Calibri" pitchFamily="34" charset="-120"/>
               </a:rPr>
-              <a:t>277 automated tests; results are re-derived from recordings on every change.</a:t>
+              <a:t>279 automated tests; results are re-derived from recordings on every change.</a:t>
             </a:r>
             <a:endParaRPr lang="en-US" sz="1400" dirty="0"/>
           </a:p>
@@ -7018,7 +7624,7 @@
                 <a:ea typeface="Cambria" pitchFamily="34" charset="-122"/>
                 <a:cs typeface="Cambria" pitchFamily="34" charset="-120"/>
               </a:rPr>
-              <a:t>Where we are: tooling built, measuring starts</a:t>
+              <a:t>Where we are: tooling built, first data in</a:t>
             </a:r>
             <a:endParaRPr lang="en-US" sz="3400" dirty="0"/>
           </a:p>
@@ -7140,7 +7746,7 @@
                 <a:ea typeface="Calibri" pitchFamily="34" charset="-122"/>
                 <a:cs typeface="Calibri" pitchFamily="34" charset="-120"/>
               </a:rPr>
-              <a:t>Measurement phase: starting now</a:t>
+              <a:t>Measurement phase: first run done</a:t>
             </a:r>
             <a:endParaRPr lang="en-US" sz="1400" dirty="0"/>
           </a:p>
@@ -8063,7 +8669,7 @@
                 <a:ea typeface="Cambria" pitchFamily="34" charset="-122"/>
                 <a:cs typeface="Cambria" pitchFamily="34" charset="-120"/>
               </a:rPr>
-              <a:t>M4 starts now</a:t>
+              <a:t>M4.1 done, M4.2 next</a:t>
             </a:r>
             <a:endParaRPr lang="en-US" sz="1800" dirty="0"/>
           </a:p>
@@ -8102,7 +8708,7 @@
                 <a:ea typeface="Calibri" pitchFamily="34" charset="-122"/>
                 <a:cs typeface="Calibri" pitchFamily="34" charset="-120"/>
               </a:rPr>
-              <a:t>The first full measurement run: the whole suite, 10 repeats per task, on the baseline setup. Mostly unattended, a few days.</a:t>
+              <a:t>The whole suite ran 10 times per task: 168 runs in 5.5 hours, no tooling failures. Next: repeat with a smaller memory window (16k) and compare.</a:t>
             </a:r>
             <a:endParaRPr lang="en-US" sz="1400" dirty="0"/>
           </a:p>
@@ -8216,7 +8822,7 @@
                 <a:ea typeface="Cambria" pitchFamily="34" charset="-122"/>
                 <a:cs typeface="Cambria" pitchFamily="34" charset="-120"/>
               </a:rPr>
-              <a:t>What the first measurements show</a:t>
+              <a:t>What the first full run shows</a:t>
             </a:r>
             <a:endParaRPr lang="en-US" sz="3400" dirty="0"/>
           </a:p>
@@ -8224,14 +8830,14 @@
       </p:sp>
       <p:sp>
         <p:nvSpPr>
-          <p:cNvPr id="3" name="Chart title"/>
-          <p:cNvSpPr txBox="1"/>
-          <p:nvPr/>
-        </p:nvSpPr>
-        <p:spPr>
-          <a:xfrm>
-            <a:off x="548640" y="1463040"/>
-            <a:ext cx="6035040" cy="365760"/>
+          <p:cNvPr id="3" name="Time chart title"/>
+          <p:cNvSpPr txBox="1"/>
+          <p:nvPr/>
+        </p:nvSpPr>
+        <p:spPr>
+          <a:xfrm>
+            <a:off x="548640" y="1325880"/>
+            <a:ext cx="5364328" cy="365760"/>
           </a:xfrm>
           <a:prstGeom prst="rect">
             <a:avLst/>
@@ -8247,7 +8853,7 @@
               <a:buNone/>
             </a:pPr>
             <a:r>
-              <a:rPr lang="en-US" sz="1800" b="1" dirty="0">
+              <a:rPr lang="en-US" sz="1600" b="1" dirty="0">
                 <a:solidFill>
                   <a:schemeClr val="tx1"/>
                 </a:solidFill>
@@ -8255,9 +8861,9 @@
                 <a:ea typeface="Cambria" pitchFamily="34" charset="-122"/>
                 <a:cs typeface="Cambria" pitchFamily="34" charset="-120"/>
               </a:rPr>
-              <a:t>Where one run's time goes</a:t>
-            </a:r>
-            <a:endParaRPr lang="en-US" sz="1800" dirty="0"/>
+              <a:t>Where the time goes, by task type</a:t>
+            </a:r>
+            <a:endParaRPr lang="en-US" sz="1600" dirty="0"/>
           </a:p>
         </p:txBody>
       </p:sp>
@@ -8268,8 +8874,8 @@
           <p:nvPr/>
         </p:nvGraphicFramePr>
         <p:xfrm>
-          <a:off x="548640" y="1874520"/>
-          <a:ext cx="6035040" cy="3474720"/>
+          <a:off x="548640" y="1691640"/>
+          <a:ext cx="5364328" cy="3429000"/>
         </p:xfrm>
         <a:graphic xmlns:a="http://schemas.openxmlformats.org/drawingml/2006/main">
           <a:graphicData uri="http://schemas.openxmlformats.org/drawingml/2006/chart">
@@ -8279,38 +8885,154 @@
       </p:graphicFrame>
       <p:sp>
         <p:nvSpPr>
-          <p:cNvPr id="5" name="Chart source"/>
-          <p:cNvSpPr txBox="1"/>
-          <p:nvPr/>
-        </p:nvSpPr>
-        <p:spPr>
-          <a:xfrm>
-            <a:off x="548640" y="5486400"/>
-            <a:ext cx="6035040" cy="548640"/>
-          </a:xfrm>
-          <a:prstGeom prst="rect">
-            <a:avLst/>
-          </a:prstGeom>
-          <a:noFill/>
-          <a:ln/>
-        </p:spPr>
-        <p:txBody>
-          <a:bodyPr wrap="square" lIns="0" tIns="0" rIns="0" bIns="0" rtlCol="0" anchor="t"/>
+          <p:cNvPr id="5" name="Pass chart title"/>
+          <p:cNvSpPr txBox="1"/>
+          <p:nvPr/>
+        </p:nvSpPr>
+        <p:spPr>
+          <a:xfrm>
+            <a:off x="6278728" y="1325880"/>
+            <a:ext cx="5364328" cy="365760"/>
+          </a:xfrm>
+          <a:prstGeom prst="rect">
+            <a:avLst/>
+          </a:prstGeom>
+          <a:noFill/>
+          <a:ln/>
+        </p:spPr>
+        <p:txBody>
+          <a:bodyPr wrap="square" lIns="0" tIns="0" rIns="0" bIns="0" rtlCol="0" anchor="ctr"/>
           <a:lstStyle/>
           <a:p>
             <a:pPr indent="0" marL="0">
               <a:buNone/>
             </a:pPr>
             <a:r>
+              <a:rPr lang="en-US" sz="1600" b="1" dirty="0">
+                <a:solidFill>
+                  <a:schemeClr val="tx1"/>
+                </a:solidFill>
+                <a:latin typeface="Cambria" pitchFamily="34" charset="0"/>
+                <a:ea typeface="Cambria" pitchFamily="34" charset="-122"/>
+                <a:cs typeface="Cambria" pitchFamily="34" charset="-120"/>
+              </a:rPr>
+              <a:t>Passed out of 10 runs, per task</a:t>
+            </a:r>
+            <a:endParaRPr lang="en-US" sz="1600" dirty="0"/>
+          </a:p>
+        </p:txBody>
+      </p:sp>
+      <p:graphicFrame>
+        <p:nvGraphicFramePr>
+          <p:cNvPr id="6" name="Chart 1" descr=""/>
+          <p:cNvGraphicFramePr/>
+          <p:nvPr/>
+        </p:nvGraphicFramePr>
+        <p:xfrm>
+          <a:off x="6278728" y="1691640"/>
+          <a:ext cx="5364328" cy="3429000"/>
+        </p:xfrm>
+        <a:graphic xmlns:a="http://schemas.openxmlformats.org/drawingml/2006/main">
+          <a:graphicData uri="http://schemas.openxmlformats.org/drawingml/2006/chart">
+            <c:chart xmlns:c="http://schemas.openxmlformats.org/drawingml/2006/chart" r:id="rId2"/>
+          </a:graphicData>
+        </a:graphic>
+      </p:graphicFrame>
+      <p:sp>
+        <p:nvSpPr>
+          <p:cNvPr id="7" name="Stat card 1"/>
+          <p:cNvSpPr/>
+          <p:nvPr/>
+        </p:nvSpPr>
+        <p:spPr>
+          <a:xfrm>
+            <a:off x="548640" y="5257800"/>
+            <a:ext cx="3515258" cy="1005840"/>
+          </a:xfrm>
+          <a:prstGeom prst="roundRect">
+            <a:avLst>
+              <a:gd name="adj" fmla="val 9091"/>
+            </a:avLst>
+          </a:prstGeom>
+          <a:solidFill>
+            <a:schemeClr val="bg2"/>
+          </a:solidFill>
+          <a:ln/>
+        </p:spPr>
+      </p:sp>
+      <p:sp>
+        <p:nvSpPr>
+          <p:cNvPr id="8" name="Stat 1"/>
+          <p:cNvSpPr txBox="1"/>
+          <p:nvPr/>
+        </p:nvSpPr>
+        <p:spPr>
+          <a:xfrm>
+            <a:off x="731520" y="5257800"/>
+            <a:ext cx="1234440" cy="1005840"/>
+          </a:xfrm>
+          <a:prstGeom prst="rect">
+            <a:avLst/>
+          </a:prstGeom>
+          <a:noFill/>
+          <a:ln/>
+        </p:spPr>
+        <p:txBody>
+          <a:bodyPr wrap="square" lIns="0" tIns="0" rIns="0" bIns="0" rtlCol="0" anchor="ctr"/>
+          <a:lstStyle/>
+          <a:p>
+            <a:pPr indent="0" marL="0">
+              <a:buNone/>
+            </a:pPr>
+            <a:r>
+              <a:rPr lang="en-US" sz="3200" b="1" dirty="0">
+                <a:solidFill>
+                  <a:schemeClr val="accent6"/>
+                </a:solidFill>
+                <a:latin typeface="Cambria" pitchFamily="34" charset="0"/>
+                <a:ea typeface="Cambria" pitchFamily="34" charset="-122"/>
+                <a:cs typeface="Cambria" pitchFamily="34" charset="-120"/>
+              </a:rPr>
+              <a:t>54%</a:t>
+            </a:r>
+            <a:endParaRPr lang="en-US" sz="3200" dirty="0"/>
+          </a:p>
+        </p:txBody>
+      </p:sp>
+      <p:sp>
+        <p:nvSpPr>
+          <p:cNvPr id="9" name="Stat text 1"/>
+          <p:cNvSpPr txBox="1"/>
+          <p:nvPr/>
+        </p:nvSpPr>
+        <p:spPr>
+          <a:xfrm>
+            <a:off x="1965960" y="5303520"/>
+            <a:ext cx="1960778" cy="914400"/>
+          </a:xfrm>
+          <a:prstGeom prst="rect">
+            <a:avLst/>
+          </a:prstGeom>
+          <a:noFill/>
+          <a:ln/>
+        </p:spPr>
+        <p:txBody>
+          <a:bodyPr wrap="square" lIns="0" tIns="0" rIns="0" bIns="0" rtlCol="0" anchor="ctr"/>
+          <a:lstStyle/>
+          <a:p>
+            <a:pPr indent="0" marL="0">
+              <a:buNone/>
+            </a:pPr>
+            <a:r>
               <a:rPr lang="en-US" sz="1200" dirty="0">
                 <a:solidFill>
-                  <a:schemeClr val="accent3"/>
+                  <a:schemeClr val="tx1"/>
                 </a:solidFill>
                 <a:latin typeface="Calibri" pitchFamily="34" charset="0"/>
                 <a:ea typeface="Calibri" pitchFamily="34" charset="-122"/>
                 <a:cs typeface="Calibri" pitchFamily="34" charset="-120"/>
               </a:rPr>
-              <a:t>Source: two recorded trials on the RTX 3080. An early indication, not yet the 10-run baseline.</a:t>
+              <a:t>of the time is prefill: the model reading its instructions. The first call alone is 72% of it.</a:t>
             </a:r>
             <a:endParaRPr lang="en-US" sz="1200" dirty="0"/>
           </a:p>
@@ -8318,18 +9040,18 @@
       </p:sp>
       <p:sp>
         <p:nvSpPr>
-          <p:cNvPr id="6" name="Stat card 1"/>
+          <p:cNvPr id="10" name="Stat card 2"/>
           <p:cNvSpPr/>
           <p:nvPr/>
         </p:nvSpPr>
         <p:spPr>
           <a:xfrm>
-            <a:off x="6949440" y="1508760"/>
-            <a:ext cx="4690872" cy="1371600"/>
+            <a:off x="4338218" y="5257800"/>
+            <a:ext cx="3515258" cy="1005840"/>
           </a:xfrm>
           <a:prstGeom prst="roundRect">
             <a:avLst>
-              <a:gd name="adj" fmla="val 6667"/>
+              <a:gd name="adj" fmla="val 9091"/>
             </a:avLst>
           </a:prstGeom>
           <a:solidFill>
@@ -8340,14 +9062,14 @@
       </p:sp>
       <p:sp>
         <p:nvSpPr>
-          <p:cNvPr id="7" name="Stat 1"/>
-          <p:cNvSpPr txBox="1"/>
-          <p:nvPr/>
-        </p:nvSpPr>
-        <p:spPr>
-          <a:xfrm>
-            <a:off x="7178040" y="1508760"/>
-            <a:ext cx="1371600" cy="1371600"/>
+          <p:cNvPr id="11" name="Stat 2"/>
+          <p:cNvSpPr txBox="1"/>
+          <p:nvPr/>
+        </p:nvSpPr>
+        <p:spPr>
+          <a:xfrm>
+            <a:off x="4521098" y="5257800"/>
+            <a:ext cx="1234440" cy="1005840"/>
           </a:xfrm>
           <a:prstGeom prst="rect">
             <a:avLst/>
@@ -8363,7 +9085,7 @@
               <a:buNone/>
             </a:pPr>
             <a:r>
-              <a:rPr lang="en-US" sz="3600" b="1" dirty="0">
+              <a:rPr lang="en-US" sz="3200" b="1" dirty="0">
                 <a:solidFill>
                   <a:schemeClr val="accent6"/>
                 </a:solidFill>
@@ -8371,22 +9093,22 @@
                 <a:ea typeface="Cambria" pitchFamily="34" charset="-122"/>
                 <a:cs typeface="Cambria" pitchFamily="34" charset="-120"/>
               </a:rPr>
-              <a:t>75%</a:t>
-            </a:r>
-            <a:endParaRPr lang="en-US" sz="3600" dirty="0"/>
-          </a:p>
-        </p:txBody>
-      </p:sp>
-      <p:sp>
-        <p:nvSpPr>
-          <p:cNvPr id="8" name="Stat text 1"/>
-          <p:cNvSpPr txBox="1"/>
-          <p:nvPr/>
-        </p:nvSpPr>
-        <p:spPr>
-          <a:xfrm>
-            <a:off x="8549640" y="1600200"/>
-            <a:ext cx="2926080" cy="1188720"/>
+              <a:t>74%</a:t>
+            </a:r>
+            <a:endParaRPr lang="en-US" sz="3200" dirty="0"/>
+          </a:p>
+        </p:txBody>
+      </p:sp>
+      <p:sp>
+        <p:nvSpPr>
+          <p:cNvPr id="12" name="Stat text 2"/>
+          <p:cNvSpPr txBox="1"/>
+          <p:nvPr/>
+        </p:nvSpPr>
+        <p:spPr>
+          <a:xfrm>
+            <a:off x="5755538" y="5303520"/>
+            <a:ext cx="1960778" cy="914400"/>
           </a:xfrm>
           <a:prstGeom prst="rect">
             <a:avLst/>
@@ -8402,7 +9124,7 @@
               <a:buNone/>
             </a:pPr>
             <a:r>
-              <a:rPr lang="en-US" sz="1400" dirty="0">
+              <a:rPr lang="en-US" sz="1200" dirty="0">
                 <a:solidFill>
                   <a:schemeClr val="tx1"/>
                 </a:solidFill>
@@ -8410,26 +9132,26 @@
                 <a:ea typeface="Calibri" pitchFamily="34" charset="-122"/>
                 <a:cs typeface="Calibri" pitchFamily="34" charset="-120"/>
               </a:rPr>
-              <a:t>of the time is the model reading its instructions before it answers. The first call alone takes about 40 seconds.</a:t>
-            </a:r>
-            <a:endParaRPr lang="en-US" sz="1400" dirty="0"/>
-          </a:p>
-        </p:txBody>
-      </p:sp>
-      <p:sp>
-        <p:nvSpPr>
-          <p:cNvPr id="9" name="Stat card 2"/>
+              <a:t>of runs passed overall (104 of 140). Only 4 of 14 tasks passed every time.</a:t>
+            </a:r>
+            <a:endParaRPr lang="en-US" sz="1200" dirty="0"/>
+          </a:p>
+        </p:txBody>
+      </p:sp>
+      <p:sp>
+        <p:nvSpPr>
+          <p:cNvPr id="13" name="Stat card 3"/>
           <p:cNvSpPr/>
           <p:nvPr/>
         </p:nvSpPr>
         <p:spPr>
           <a:xfrm>
-            <a:off x="6949440" y="3063240"/>
-            <a:ext cx="4690872" cy="1371600"/>
+            <a:off x="8127797" y="5257800"/>
+            <a:ext cx="3515258" cy="1005840"/>
           </a:xfrm>
           <a:prstGeom prst="roundRect">
             <a:avLst>
-              <a:gd name="adj" fmla="val 6667"/>
+              <a:gd name="adj" fmla="val 9091"/>
             </a:avLst>
           </a:prstGeom>
           <a:solidFill>
@@ -8440,14 +9162,14 @@
       </p:sp>
       <p:sp>
         <p:nvSpPr>
-          <p:cNvPr id="10" name="Stat 2"/>
-          <p:cNvSpPr txBox="1"/>
-          <p:nvPr/>
-        </p:nvSpPr>
-        <p:spPr>
-          <a:xfrm>
-            <a:off x="7178040" y="3063240"/>
-            <a:ext cx="1371600" cy="1371600"/>
+          <p:cNvPr id="14" name="Stat 3"/>
+          <p:cNvSpPr txBox="1"/>
+          <p:nvPr/>
+        </p:nvSpPr>
+        <p:spPr>
+          <a:xfrm>
+            <a:off x="8310677" y="5257800"/>
+            <a:ext cx="1234440" cy="1005840"/>
           </a:xfrm>
           <a:prstGeom prst="rect">
             <a:avLst/>
@@ -8463,7 +9185,7 @@
               <a:buNone/>
             </a:pPr>
             <a:r>
-              <a:rPr lang="en-US" sz="3600" b="1" dirty="0">
+              <a:rPr lang="en-US" sz="3200" b="1" dirty="0">
                 <a:solidFill>
                   <a:schemeClr val="accent6"/>
                 </a:solidFill>
@@ -8471,22 +9193,22 @@
                 <a:ea typeface="Cambria" pitchFamily="34" charset="-122"/>
                 <a:cs typeface="Cambria" pitchFamily="34" charset="-120"/>
               </a:rPr>
-              <a:t>10%</a:t>
-            </a:r>
-            <a:endParaRPr lang="en-US" sz="3600" dirty="0"/>
-          </a:p>
-        </p:txBody>
-      </p:sp>
-      <p:sp>
-        <p:nvSpPr>
-          <p:cNvPr id="11" name="Stat text 2"/>
-          <p:cNvSpPr txBox="1"/>
-          <p:nvPr/>
-        </p:nvSpPr>
-        <p:spPr>
-          <a:xfrm>
-            <a:off x="8549640" y="3154680"/>
-            <a:ext cx="2926080" cy="1188720"/>
+              <a:t>1%</a:t>
+            </a:r>
+            <a:endParaRPr lang="en-US" sz="3200" dirty="0"/>
+          </a:p>
+        </p:txBody>
+      </p:sp>
+      <p:sp>
+        <p:nvSpPr>
+          <p:cNvPr id="15" name="Stat text 3"/>
+          <p:cNvSpPr txBox="1"/>
+          <p:nvPr/>
+        </p:nvSpPr>
+        <p:spPr>
+          <a:xfrm>
+            <a:off x="9545117" y="5303520"/>
+            <a:ext cx="1960778" cy="914400"/>
           </a:xfrm>
           <a:prstGeom prst="rect">
             <a:avLst/>
@@ -8502,7 +9224,7 @@
               <a:buNone/>
             </a:pPr>
             <a:r>
-              <a:rPr lang="en-US" sz="1400" dirty="0">
+              <a:rPr lang="en-US" sz="1200" dirty="0">
                 <a:solidFill>
                   <a:schemeClr val="tx1"/>
                 </a:solidFill>
@@ -8510,109 +9232,9 @@
                 <a:ea typeface="Calibri" pitchFamily="34" charset="-122"/>
                 <a:cs typeface="Calibri" pitchFamily="34" charset="-120"/>
               </a:rPr>
-              <a:t>is how much of the answering time the GPU is really busy. This card holds only part of the model, so the processor is the bottleneck.</a:t>
-            </a:r>
-            <a:endParaRPr lang="en-US" sz="1400" dirty="0"/>
-          </a:p>
-        </p:txBody>
-      </p:sp>
-      <p:sp>
-        <p:nvSpPr>
-          <p:cNvPr id="12" name="Stat card 3"/>
-          <p:cNvSpPr/>
-          <p:nvPr/>
-        </p:nvSpPr>
-        <p:spPr>
-          <a:xfrm>
-            <a:off x="6949440" y="4617720"/>
-            <a:ext cx="4690872" cy="1371600"/>
-          </a:xfrm>
-          <a:prstGeom prst="roundRect">
-            <a:avLst>
-              <a:gd name="adj" fmla="val 6667"/>
-            </a:avLst>
-          </a:prstGeom>
-          <a:solidFill>
-            <a:schemeClr val="bg2"/>
-          </a:solidFill>
-          <a:ln/>
-        </p:spPr>
-      </p:sp>
-      <p:sp>
-        <p:nvSpPr>
-          <p:cNvPr id="13" name="Stat 3"/>
-          <p:cNvSpPr txBox="1"/>
-          <p:nvPr/>
-        </p:nvSpPr>
-        <p:spPr>
-          <a:xfrm>
-            <a:off x="7178040" y="4617720"/>
-            <a:ext cx="1371600" cy="1371600"/>
-          </a:xfrm>
-          <a:prstGeom prst="rect">
-            <a:avLst/>
-          </a:prstGeom>
-          <a:noFill/>
-          <a:ln/>
-        </p:spPr>
-        <p:txBody>
-          <a:bodyPr wrap="square" lIns="0" tIns="0" rIns="0" bIns="0" rtlCol="0" anchor="ctr"/>
-          <a:lstStyle/>
-          <a:p>
-            <a:pPr indent="0" marL="0">
-              <a:buNone/>
-            </a:pPr>
-            <a:r>
-              <a:rPr lang="en-US" sz="3600" b="1" dirty="0">
-                <a:solidFill>
-                  <a:schemeClr val="accent6"/>
-                </a:solidFill>
-                <a:latin typeface="Cambria" pitchFamily="34" charset="0"/>
-                <a:ea typeface="Cambria" pitchFamily="34" charset="-122"/>
-                <a:cs typeface="Cambria" pitchFamily="34" charset="-120"/>
-              </a:rPr>
-              <a:t>40%</a:t>
-            </a:r>
-            <a:endParaRPr lang="en-US" sz="3600" dirty="0"/>
-          </a:p>
-        </p:txBody>
-      </p:sp>
-      <p:sp>
-        <p:nvSpPr>
-          <p:cNvPr id="14" name="Stat text 3"/>
-          <p:cNvSpPr txBox="1"/>
-          <p:nvPr/>
-        </p:nvSpPr>
-        <p:spPr>
-          <a:xfrm>
-            <a:off x="8549640" y="4709160"/>
-            <a:ext cx="2926080" cy="1188720"/>
-          </a:xfrm>
-          <a:prstGeom prst="rect">
-            <a:avLst/>
-          </a:prstGeom>
-          <a:noFill/>
-          <a:ln/>
-        </p:spPr>
-        <p:txBody>
-          <a:bodyPr wrap="square" lIns="0" tIns="0" rIns="0" bIns="0" rtlCol="0" anchor="ctr"/>
-          <a:lstStyle/>
-          <a:p>
-            <a:pPr indent="0" marL="0">
-              <a:buNone/>
-            </a:pPr>
-            <a:r>
-              <a:rPr lang="en-US" sz="1400" dirty="0">
-                <a:solidFill>
-                  <a:schemeClr val="tx1"/>
-                </a:solidFill>
-                <a:latin typeface="Calibri" pitchFamily="34" charset="0"/>
-                <a:ea typeface="Calibri" pitchFamily="34" charset="-122"/>
-                <a:cs typeface="Calibri" pitchFamily="34" charset="-120"/>
-              </a:rPr>
-              <a:t>is the true pass rate of two tasks that passed in single runs. Repeating tests matters.</a:t>
-            </a:r>
-            <a:endParaRPr lang="en-US" sz="1400" dirty="0"/>
+              <a:t>of the time is spent in tools. Faster tools would not help; shorter prompts might.</a:t>
+            </a:r>
+            <a:endParaRPr lang="en-US" sz="1200" dirty="0"/>
           </a:p>
         </p:txBody>
       </p:sp>
@@ -8863,7 +9485,7 @@
                 <a:ea typeface="Calibri" pitchFamily="34" charset="-122"/>
                 <a:cs typeface="Calibri" pitchFamily="34" charset="-120"/>
               </a:rPr>
-              <a:t>3 to 4 days, mostly unattended</a:t>
+              <a:t>first run done; 16k run about 5 hours</a:t>
             </a:r>
             <a:endParaRPr lang="en-US" sz="1400" dirty="0"/>
           </a:p>
@@ -8906,7 +9528,7 @@
                 <a:ea typeface="Calibri" pitchFamily="34" charset="-122"/>
                 <a:cs typeface="Calibri" pitchFamily="34" charset="-120"/>
               </a:rPr>
-              <a:t>Whole suite, 10 repeats per task</a:t>
+              <a:t>Done: whole suite, 10 repeats per task</a:t>
             </a:r>
             <a:endParaRPr lang="en-US" sz="1400" dirty="0"/>
           </a:p>
@@ -8927,7 +9549,7 @@
                 <a:ea typeface="Calibri" pitchFamily="34" charset="-122"/>
                 <a:cs typeface="Calibri" pitchFamily="34" charset="-120"/>
               </a:rPr>
-              <a:t>Re-check the earlier 16k vs 32k finding</a:t>
+              <a:t>Next: re-check the earlier 16k vs 32k finding</a:t>
             </a:r>
             <a:endParaRPr lang="en-US" sz="1400" dirty="0"/>
           </a:p>
@@ -8948,7 +9570,7 @@
                 <a:ea typeface="Calibri" pitchFamily="34" charset="-122"/>
                 <a:cs typeface="Calibri" pitchFamily="34" charset="-120"/>
               </a:rPr>
-              <a:t>Time breakdown per task type</a:t>
+              <a:t>Time breakdown per task type (done for 32k)</a:t>
             </a:r>
             <a:endParaRPr lang="en-US" sz="1400" dirty="0"/>
           </a:p>

</xml_diff>

<commit_message>
P8: prompt-budget analysis; isolation leak and cache findings
</commit_message>
<xml_diff>
--- a/Doc/Agent_opt.pptx
+++ b/Doc/Agent_opt.pptx
@@ -116,26 +116,26 @@
   <p:extLst>
     <p:ext uri="{521415D9-36F7-43E2-AB2F-B90AF26B5E84}">
       <p14:sectionLst xmlns:p14="http://schemas.microsoft.com/office/powerpoint/2010/main">
-        <p14:section name="Purpose" id="{0f38b0b2-aabc-0a5e-b521-10204035a18e}">
+        <p14:section name="Purpose" id="{68df03e0-6612-b932-f709-71028cff7636}">
           <p14:sldIdLst>
             <p14:sldId id="256"/>
             <p14:sldId id="257"/>
             <p14:sldId id="258"/>
           </p14:sldIdLst>
         </p14:section>
-        <p14:section name="Method" id="{0f2eed75-6f4f-3b31-9fd3-7231e8663dbf}">
+        <p14:section name="Method" id="{e028df71-f03f-5ac9-b3c7-8847185f9347}">
           <p14:sldIdLst>
             <p14:sldId id="259"/>
             <p14:sldId id="260"/>
           </p14:sldIdLst>
         </p14:section>
-        <p14:section name="Status" id="{73430d65-2277-bcb6-e4ac-d530ac0e9f76}">
+        <p14:section name="Status" id="{a9f9476e-b50b-9d47-deb8-7cd7c1f4711a}">
           <p14:sldIdLst>
             <p14:sldId id="261"/>
             <p14:sldId id="262"/>
           </p14:sldIdLst>
         </p14:section>
-        <p14:section name="Next" id="{ba01265d-3d94-c75b-0565-91ef4b505124}">
+        <p14:section name="Next" id="{163183c2-bbb1-62c6-2ff3-c2cdd5800067}">
           <p14:sldIdLst>
             <p14:sldId id="263"/>
             <p14:sldId id="264"/>
@@ -2032,7 +2032,7 @@
           <a:p>
             <a:r>
               <a:rPr lang="en-US" dirty="0"/>
-              <a:t>Source: the baseline run, 14 tasks x 10 runs at the 32k setting, 140 measured runs. Left: share of wall-clock time; the model's reading of its instructions (prefill) dominates for long-context and reasoning tasks, writing the answer dominates for code generation. Right: runs passed per task; with 10 runs each, only the extremes are clearly different (the research task needs a larger memory window and passed 1 of 10). The earlier two-run pilot suggested 75 percent prefill; the full run shows 54 percent overall, so that early figure applied only to short read-heavy tasks. Instrumentation overhead check is still inconclusive.</a:t>
+              <a:t>Source: the baseline run, 14 tasks x 10 runs at the 32k setting, 140 measured runs. Left: share of wall-clock time; the model's reading of its instructions (prefill) dominates for long-context and reasoning tasks, writing the answer dominates for code generation. Right: runs passed per task; with 10 runs each, only the extremes are clearly different (the research task needs a larger memory window and passed 1 of 10). The earlier two-run pilot suggested 75 percent prefill; the full run shows 54 percent overall, so that early figure applied only to short read-heavy tasks. Instrumentation overhead check is still inconclusive. Later analysis found that every run re-reads a 10,000-token prompt from scratch (about 40 seconds, a third of all time) and that part of that prompt came from the author's personal setup; the baseline will be repeated with that removed.</a:t>
             </a:r>
             <a:endParaRPr lang="en-US" dirty="0"/>
           </a:p>
@@ -3067,7 +3067,7 @@
                 <a:ea typeface="Cambria" pitchFamily="34" charset="-122"/>
                 <a:cs typeface="Cambria" pitchFamily="34" charset="-120"/>
               </a:rPr>
-              <a:t>279</a:t>
+              <a:t>285</a:t>
             </a:r>
             <a:endParaRPr lang="en-US" sz="4400" dirty="0"/>
           </a:p>
@@ -7366,7 +7366,7 @@
                 <a:ea typeface="Calibri" pitchFamily="34" charset="-122"/>
                 <a:cs typeface="Calibri" pitchFamily="34" charset="-120"/>
               </a:rPr>
-              <a:t>279 automated tests; results are re-derived from recordings on every change.</a:t>
+              <a:t>285 automated tests; results are re-derived from recordings on every change.</a:t>
             </a:r>
             <a:endParaRPr lang="en-US" sz="1400" dirty="0"/>
           </a:p>
@@ -9032,7 +9032,7 @@
                 <a:ea typeface="Calibri" pitchFamily="34" charset="-122"/>
                 <a:cs typeface="Calibri" pitchFamily="34" charset="-120"/>
               </a:rPr>
-              <a:t>of the time is prefill: the model reading its instructions. The first call alone is 72% of it.</a:t>
+              <a:t>of the time is prefill: the model reading its instructions. The first call of each run is 62% of it.</a:t>
             </a:r>
             <a:endParaRPr lang="en-US" sz="1200" dirty="0"/>
           </a:p>

</xml_diff>

<commit_message>
Isolated re-baseline: results, comparison, stall detector, docs
Re-run the full suite with OpenCode isolated from the author's ~/.claude setup
(results/v1/baseline_isolated, COMPARISON.md): about 42% faster per trial,
success unchanged within noise, 130/140 first calls warm. Add the runner stall
detector (P13), analysis/compare_runs.py, the prompt-budget cold-rate fix, and
update README, plan and deck. The hung parity trial is kept in hung_trials/
and its re-run passed.
</commit_message>
<xml_diff>
--- a/Doc/Agent_opt.pptx
+++ b/Doc/Agent_opt.pptx
@@ -116,26 +116,26 @@
   <p:extLst>
     <p:ext uri="{521415D9-36F7-43E2-AB2F-B90AF26B5E84}">
       <p14:sectionLst xmlns:p14="http://schemas.microsoft.com/office/powerpoint/2010/main">
-        <p14:section name="Purpose" id="{68df03e0-6612-b932-f709-71028cff7636}">
+        <p14:section name="Purpose" id="{5ef119da-be18-3ab8-5110-a579815220dd}">
           <p14:sldIdLst>
             <p14:sldId id="256"/>
             <p14:sldId id="257"/>
             <p14:sldId id="258"/>
           </p14:sldIdLst>
         </p14:section>
-        <p14:section name="Method" id="{e028df71-f03f-5ac9-b3c7-8847185f9347}">
+        <p14:section name="Method" id="{1529a4f8-cc56-f809-b822-1a52da11bd0f}">
           <p14:sldIdLst>
             <p14:sldId id="259"/>
             <p14:sldId id="260"/>
           </p14:sldIdLst>
         </p14:section>
-        <p14:section name="Status" id="{a9f9476e-b50b-9d47-deb8-7cd7c1f4711a}">
+        <p14:section name="Status" id="{1f235bdf-0f94-5018-4c1b-f0d183177f49}">
           <p14:sldIdLst>
             <p14:sldId id="261"/>
             <p14:sldId id="262"/>
           </p14:sldIdLst>
         </p14:section>
-        <p14:section name="Next" id="{163183c2-bbb1-62c6-2ff3-c2cdd5800067}">
+        <p14:section name="Next" id="{e5331f51-c785-3da5-5f23-ac682e38d448}">
           <p14:sldIdLst>
             <p14:sldId id="263"/>
             <p14:sldId id="264"/>
@@ -218,31 +218,31 @@
                     <c:v>Long context</c:v>
                   </c:pt>
                   <c:pt idx="1">
+                    <c:v>Log triage</c:v>
+                  </c:pt>
+                  <c:pt idx="2">
+                    <c:v>Research</c:v>
+                  </c:pt>
+                  <c:pt idx="3">
+                    <c:v>Refactor</c:v>
+                  </c:pt>
+                  <c:pt idx="4">
+                    <c:v>Bug fix</c:v>
+                  </c:pt>
+                  <c:pt idx="5">
+                    <c:v>Repo Q&amp;A</c:v>
+                  </c:pt>
+                  <c:pt idx="6">
+                    <c:v>Email / calendar</c:v>
+                  </c:pt>
+                  <c:pt idx="7">
                     <c:v>Reasoning</c:v>
                   </c:pt>
-                  <c:pt idx="2">
-                    <c:v>Bug fix</c:v>
-                  </c:pt>
-                  <c:pt idx="3">
-                    <c:v>Repo Q&amp;A</c:v>
-                  </c:pt>
-                  <c:pt idx="4">
-                    <c:v>Research</c:v>
-                  </c:pt>
-                  <c:pt idx="5">
-                    <c:v>Log triage</c:v>
-                  </c:pt>
-                  <c:pt idx="6">
-                    <c:v>Code review</c:v>
-                  </c:pt>
-                  <c:pt idx="7">
-                    <c:v>Refactor</c:v>
-                  </c:pt>
                   <c:pt idx="8">
-                    <c:v>Email / calendar</c:v>
+                    <c:v>Code generation</c:v>
                   </c:pt>
                   <c:pt idx="9">
-                    <c:v>Code generation</c:v>
+                    <c:v>Code review</c:v>
                   </c:pt>
                   <c:pt idx="10">
                     <c:v>All tasks</c:v>
@@ -258,37 +258,37 @@
                 <c:formatCode>General</c:formatCode>
                 <c:ptCount val="11"/>
                 <c:pt idx="0">
-                  <c:v>80.7</c:v>
+                  <c:v>70.9</c:v>
                 </c:pt>
                 <c:pt idx="1">
-                  <c:v>79.8</c:v>
+                  <c:v>63.6</c:v>
                 </c:pt>
                 <c:pt idx="2">
-                  <c:v>70</c:v>
+                  <c:v>56.7</c:v>
                 </c:pt>
                 <c:pt idx="3">
-                  <c:v>68</c:v>
+                  <c:v>40</c:v>
                 </c:pt>
                 <c:pt idx="4">
-                  <c:v>67.4</c:v>
+                  <c:v>36.3</c:v>
                 </c:pt>
                 <c:pt idx="5">
-                  <c:v>65.3</c:v>
+                  <c:v>35.1</c:v>
                 </c:pt>
                 <c:pt idx="6">
-                  <c:v>57</c:v>
+                  <c:v>31.3</c:v>
                 </c:pt>
                 <c:pt idx="7">
-                  <c:v>53.9</c:v>
+                  <c:v>28</c:v>
                 </c:pt>
                 <c:pt idx="8">
-                  <c:v>48.3</c:v>
+                  <c:v>16.2</c:v>
                 </c:pt>
                 <c:pt idx="9">
-                  <c:v>36.6</c:v>
+                  <c:v>11.1</c:v>
                 </c:pt>
                 <c:pt idx="10">
-                  <c:v>54</c:v>
+                  <c:v>33.1</c:v>
                 </c:pt>
               </c:numCache>
             </c:numRef>
@@ -349,31 +349,31 @@
                     <c:v>Long context</c:v>
                   </c:pt>
                   <c:pt idx="1">
+                    <c:v>Log triage</c:v>
+                  </c:pt>
+                  <c:pt idx="2">
+                    <c:v>Research</c:v>
+                  </c:pt>
+                  <c:pt idx="3">
+                    <c:v>Refactor</c:v>
+                  </c:pt>
+                  <c:pt idx="4">
+                    <c:v>Bug fix</c:v>
+                  </c:pt>
+                  <c:pt idx="5">
+                    <c:v>Repo Q&amp;A</c:v>
+                  </c:pt>
+                  <c:pt idx="6">
+                    <c:v>Email / calendar</c:v>
+                  </c:pt>
+                  <c:pt idx="7">
                     <c:v>Reasoning</c:v>
                   </c:pt>
-                  <c:pt idx="2">
-                    <c:v>Bug fix</c:v>
-                  </c:pt>
-                  <c:pt idx="3">
-                    <c:v>Repo Q&amp;A</c:v>
-                  </c:pt>
-                  <c:pt idx="4">
-                    <c:v>Research</c:v>
-                  </c:pt>
-                  <c:pt idx="5">
-                    <c:v>Log triage</c:v>
-                  </c:pt>
-                  <c:pt idx="6">
-                    <c:v>Code review</c:v>
-                  </c:pt>
-                  <c:pt idx="7">
-                    <c:v>Refactor</c:v>
-                  </c:pt>
                   <c:pt idx="8">
-                    <c:v>Email / calendar</c:v>
+                    <c:v>Code generation</c:v>
                   </c:pt>
                   <c:pt idx="9">
-                    <c:v>Code generation</c:v>
+                    <c:v>Code review</c:v>
                   </c:pt>
                   <c:pt idx="10">
                     <c:v>All tasks</c:v>
@@ -389,37 +389,37 @@
                 <c:formatCode>General</c:formatCode>
                 <c:ptCount val="11"/>
                 <c:pt idx="0">
-                  <c:v>17.3</c:v>
+                  <c:v>26.2</c:v>
                 </c:pt>
                 <c:pt idx="1">
-                  <c:v>16.4</c:v>
+                  <c:v>34.8</c:v>
                 </c:pt>
                 <c:pt idx="2">
-                  <c:v>27.2</c:v>
+                  <c:v>36.9</c:v>
                 </c:pt>
                 <c:pt idx="3">
-                  <c:v>29.2</c:v>
+                  <c:v>57.5</c:v>
                 </c:pt>
                 <c:pt idx="4">
-                  <c:v>30.1</c:v>
+                  <c:v>58.2</c:v>
                 </c:pt>
                 <c:pt idx="5">
-                  <c:v>33.2</c:v>
+                  <c:v>59</c:v>
                 </c:pt>
                 <c:pt idx="6">
-                  <c:v>40.4</c:v>
+                  <c:v>55.4</c:v>
                 </c:pt>
                 <c:pt idx="7">
-                  <c:v>44.1</c:v>
+                  <c:v>59.4</c:v>
                 </c:pt>
                 <c:pt idx="8">
-                  <c:v>39.9</c:v>
+                  <c:v>76.8</c:v>
                 </c:pt>
                 <c:pt idx="9">
-                  <c:v>60.3</c:v>
+                  <c:v>85.1</c:v>
                 </c:pt>
                 <c:pt idx="10">
-                  <c:v>42.7</c:v>
+                  <c:v>60.5</c:v>
                 </c:pt>
               </c:numCache>
             </c:numRef>
@@ -480,31 +480,31 @@
                     <c:v>Long context</c:v>
                   </c:pt>
                   <c:pt idx="1">
+                    <c:v>Log triage</c:v>
+                  </c:pt>
+                  <c:pt idx="2">
+                    <c:v>Research</c:v>
+                  </c:pt>
+                  <c:pt idx="3">
+                    <c:v>Refactor</c:v>
+                  </c:pt>
+                  <c:pt idx="4">
+                    <c:v>Bug fix</c:v>
+                  </c:pt>
+                  <c:pt idx="5">
+                    <c:v>Repo Q&amp;A</c:v>
+                  </c:pt>
+                  <c:pt idx="6">
+                    <c:v>Email / calendar</c:v>
+                  </c:pt>
+                  <c:pt idx="7">
                     <c:v>Reasoning</c:v>
                   </c:pt>
-                  <c:pt idx="2">
-                    <c:v>Bug fix</c:v>
-                  </c:pt>
-                  <c:pt idx="3">
-                    <c:v>Repo Q&amp;A</c:v>
-                  </c:pt>
-                  <c:pt idx="4">
-                    <c:v>Research</c:v>
-                  </c:pt>
-                  <c:pt idx="5">
-                    <c:v>Log triage</c:v>
-                  </c:pt>
-                  <c:pt idx="6">
-                    <c:v>Code review</c:v>
-                  </c:pt>
-                  <c:pt idx="7">
-                    <c:v>Refactor</c:v>
-                  </c:pt>
                   <c:pt idx="8">
-                    <c:v>Email / calendar</c:v>
+                    <c:v>Code generation</c:v>
                   </c:pt>
                   <c:pt idx="9">
-                    <c:v>Code generation</c:v>
+                    <c:v>Code review</c:v>
                   </c:pt>
                   <c:pt idx="10">
                     <c:v>All tasks</c:v>
@@ -520,37 +520,37 @@
                 <c:formatCode>General</c:formatCode>
                 <c:ptCount val="11"/>
                 <c:pt idx="0">
-                  <c:v>1.9</c:v>
+                  <c:v>3</c:v>
                 </c:pt>
                 <c:pt idx="1">
-                  <c:v>3.8</c:v>
+                  <c:v>1.5</c:v>
                 </c:pt>
                 <c:pt idx="2">
-                  <c:v>2.8</c:v>
+                  <c:v>6.4</c:v>
                 </c:pt>
                 <c:pt idx="3">
-                  <c:v>2.8</c:v>
+                  <c:v>2.5</c:v>
                 </c:pt>
                 <c:pt idx="4">
-                  <c:v>2.4</c:v>
+                  <c:v>5.5</c:v>
                 </c:pt>
                 <c:pt idx="5">
-                  <c:v>1.5</c:v>
+                  <c:v>5.9</c:v>
                 </c:pt>
                 <c:pt idx="6">
-                  <c:v>2.5</c:v>
+                  <c:v>13.2</c:v>
                 </c:pt>
                 <c:pt idx="7">
-                  <c:v>2</c:v>
+                  <c:v>12.6</c:v>
                 </c:pt>
                 <c:pt idx="8">
-                  <c:v>11.8</c:v>
+                  <c:v>7</c:v>
                 </c:pt>
                 <c:pt idx="9">
-                  <c:v>3</c:v>
+                  <c:v>3.9</c:v>
                 </c:pt>
                 <c:pt idx="10">
-                  <c:v>3.3</c:v>
+                  <c:v>6.3</c:v>
                 </c:pt>
               </c:numCache>
             </c:numRef>
@@ -788,10 +788,10 @@
                 <c:ptCount val="14"/>
                 <c:lvl>
                   <c:pt idx="0">
-                    <c:v>Dir stats (code gen)</c:v>
+                    <c:v>Moving average (bugfix)</c:v>
                   </c:pt>
                   <c:pt idx="1">
-                    <c:v>Scientific (reasoning)</c:v>
+                    <c:v>Dir stats (code gen)</c:v>
                   </c:pt>
                   <c:pt idx="2">
                     <c:v>Confirm send (comms)</c:v>
@@ -800,28 +800,28 @@
                     <c:v>Tidal report (long ctx)</c:v>
                   </c:pt>
                   <c:pt idx="4">
-                    <c:v>Rename (refactor)</c:v>
+                    <c:v>Scientific (reasoning)</c:v>
                   </c:pt>
                   <c:pt idx="5">
-                    <c:v>Moving average (bugfix)</c:v>
+                    <c:v>Rename (refactor)</c:v>
                   </c:pt>
                   <c:pt idx="6">
                     <c:v>FizzBuzz (code gen)</c:v>
                   </c:pt>
                   <c:pt idx="7">
+                    <c:v>Pool exhaustion (logs)</c:v>
+                  </c:pt>
+                  <c:pt idx="8">
                     <c:v>Compression (code gen)</c:v>
                   </c:pt>
-                  <c:pt idx="8">
-                    <c:v>Pool exhaustion (logs)</c:v>
+                  <c:pt idx="9">
+                    <c:v>sqrt (code review)</c:v>
                   </c:pt>
-                  <c:pt idx="9">
+                  <c:pt idx="10">
                     <c:v>Retry policy (repo Q&amp;A)</c:v>
                   </c:pt>
-                  <c:pt idx="10">
+                  <c:pt idx="11">
                     <c:v>Ring buffer (code gen)</c:v>
-                  </c:pt>
-                  <c:pt idx="11">
-                    <c:v>sqrt (code review)</c:v>
                   </c:pt>
                   <c:pt idx="12">
                     <c:v>Tax rates (reasoning)</c:v>
@@ -855,7 +855,7 @@
                   <c:v>9</c:v>
                 </c:pt>
                 <c:pt idx="5">
-                  <c:v>8</c:v>
+                  <c:v>9</c:v>
                 </c:pt>
                 <c:pt idx="6">
                   <c:v>8</c:v>
@@ -864,22 +864,22 @@
                   <c:v>8</c:v>
                 </c:pt>
                 <c:pt idx="8">
-                  <c:v>8</c:v>
+                  <c:v>6</c:v>
                 </c:pt>
                 <c:pt idx="9">
-                  <c:v>7</c:v>
+                  <c:v>5</c:v>
                 </c:pt>
                 <c:pt idx="10">
-                  <c:v>6</c:v>
+                  <c:v>5</c:v>
                 </c:pt>
                 <c:pt idx="11">
-                  <c:v>6</c:v>
+                  <c:v>3</c:v>
                 </c:pt>
                 <c:pt idx="12">
                   <c:v>3</c:v>
                 </c:pt>
                 <c:pt idx="13">
-                  <c:v>1</c:v>
+                  <c:v>3</c:v>
                 </c:pt>
               </c:numCache>
             </c:numRef>
@@ -2032,7 +2032,7 @@
           <a:p>
             <a:r>
               <a:rPr lang="en-US" dirty="0"/>
-              <a:t>Source: the baseline run, 14 tasks x 10 runs at the 32k setting, 140 measured runs. Left: share of wall-clock time; the model's reading of its instructions (prefill) dominates for long-context and reasoning tasks, writing the answer dominates for code generation. Right: runs passed per task; with 10 runs each, only the extremes are clearly different (the research task needs a larger memory window and passed 1 of 10). The earlier two-run pilot suggested 75 percent prefill; the full run shows 54 percent overall, so that early figure applied only to short read-heavy tasks. Instrumentation overhead check is still inconclusive. Later analysis found that every run re-reads a 10,000-token prompt from scratch (about 40 seconds, a third of all time) and that part of that prompt came from the author's personal setup; the baseline will be repeated with that removed.</a:t>
+              <a:t>Source: the isolated baseline run, 14 tasks x 10 runs at the 32k setting, 140 measured runs. Left: share of wall-clock time; the model's reading of its instructions (prefill) dominates for long-context and reasoning tasks, writing the answer dominates for code generation. Right: runs passed per task; with 10 runs each, only the extremes are clearly different (the research task needs a larger memory window and passed 1 of 10). The earlier two-run pilot suggested 75 percent prefill; the first full run showed 54 percent, and after the leaked block was removed it is 33 percent, with writing the answer now the largest share (60 percent). The 42 percent speed-up is a median over all tasks, with a confidence range of 37 to 48 percent. About 40 percent of the saved time comes from the shorter prompt and the rest from the model reusing its already-processed prompt between runs; that second part depends on runs following each other. Instrumentation overhead check is still inconclusive.</a:t>
             </a:r>
             <a:endParaRPr lang="en-US" dirty="0"/>
           </a:p>
@@ -3067,7 +3067,7 @@
                 <a:ea typeface="Cambria" pitchFamily="34" charset="-122"/>
                 <a:cs typeface="Cambria" pitchFamily="34" charset="-120"/>
               </a:rPr>
-              <a:t>285</a:t>
+              <a:t>289</a:t>
             </a:r>
             <a:endParaRPr lang="en-US" sz="4400" dirty="0"/>
           </a:p>
@@ -3145,7 +3145,7 @@
                 <a:ea typeface="Cambria" pitchFamily="34" charset="-122"/>
                 <a:cs typeface="Cambria" pitchFamily="34" charset="-120"/>
               </a:rPr>
-              <a:t>168</a:t>
+              <a:t>336</a:t>
             </a:r>
             <a:endParaRPr lang="en-US" sz="4400" dirty="0"/>
           </a:p>
@@ -3184,7 +3184,7 @@
                 <a:ea typeface="Calibri" pitchFamily="34" charset="-122"/>
                 <a:cs typeface="Calibri" pitchFamily="34" charset="-120"/>
               </a:rPr>
-              <a:t>baseline runs measured, no tooling failures</a:t>
+              <a:t>baseline runs recorded in two full passes</a:t>
             </a:r>
             <a:endParaRPr lang="en-US" sz="1400" dirty="0"/>
           </a:p>
@@ -3433,7 +3433,7 @@
                 <a:ea typeface="Calibri" pitchFamily="34" charset="-122"/>
                 <a:cs typeface="Calibri" pitchFamily="34" charset="-120"/>
               </a:rPr>
-              <a:t>10 repeats took 5.5 hours for one setup; the full sweep is about 35 to 40 hours of GPU time.</a:t>
+              <a:t>10 repeats took about 4.3 hours for one setup; the full sweep is estimated at 25 hours of GPU time.</a:t>
             </a:r>
             <a:endParaRPr lang="en-US" sz="1400" dirty="0"/>
           </a:p>
@@ -7366,7 +7366,7 @@
                 <a:ea typeface="Calibri" pitchFamily="34" charset="-122"/>
                 <a:cs typeface="Calibri" pitchFamily="34" charset="-120"/>
               </a:rPr>
-              <a:t>285 automated tests; results are re-derived from recordings on every change.</a:t>
+              <a:t>289 automated tests; results are re-derived from recordings on every change.</a:t>
             </a:r>
             <a:endParaRPr lang="en-US" sz="1400" dirty="0"/>
           </a:p>
@@ -8708,7 +8708,7 @@
                 <a:ea typeface="Calibri" pitchFamily="34" charset="-122"/>
                 <a:cs typeface="Calibri" pitchFamily="34" charset="-120"/>
               </a:rPr>
-              <a:t>The whole suite ran 10 times per task: 168 runs in 5.5 hours, no tooling failures. Next: repeat with a smaller memory window (16k) and compare.</a:t>
+              <a:t>The whole suite ran 10 times per task, twice (336 runs). Removing a leaked block from the prompt made runs about 42% faster. Next: repeat with a smaller memory window (16k).</a:t>
             </a:r>
             <a:endParaRPr lang="en-US" sz="1400" dirty="0"/>
           </a:p>
@@ -8822,7 +8822,7 @@
                 <a:ea typeface="Cambria" pitchFamily="34" charset="-122"/>
                 <a:cs typeface="Cambria" pitchFamily="34" charset="-120"/>
               </a:rPr>
-              <a:t>What the first full run shows</a:t>
+              <a:t>What the baseline shows</a:t>
             </a:r>
             <a:endParaRPr lang="en-US" sz="3400" dirty="0"/>
           </a:p>
@@ -8993,7 +8993,7 @@
                 <a:ea typeface="Cambria" pitchFamily="34" charset="-122"/>
                 <a:cs typeface="Cambria" pitchFamily="34" charset="-120"/>
               </a:rPr>
-              <a:t>54%</a:t>
+              <a:t>42%</a:t>
             </a:r>
             <a:endParaRPr lang="en-US" sz="3200" dirty="0"/>
           </a:p>
@@ -9032,7 +9032,7 @@
                 <a:ea typeface="Calibri" pitchFamily="34" charset="-122"/>
                 <a:cs typeface="Calibri" pitchFamily="34" charset="-120"/>
               </a:rPr>
-              <a:t>of the time is prefill: the model reading its instructions. The first call of each run is 62% of it.</a:t>
+              <a:t>faster per run once a block of personal setup was removed from the prompt. Success is unchanged within noise (71% vs 74%).</a:t>
             </a:r>
             <a:endParaRPr lang="en-US" sz="1200" dirty="0"/>
           </a:p>
@@ -9093,7 +9093,7 @@
                 <a:ea typeface="Cambria" pitchFamily="34" charset="-122"/>
                 <a:cs typeface="Cambria" pitchFamily="34" charset="-120"/>
               </a:rPr>
-              <a:t>74%</a:t>
+              <a:t>60%</a:t>
             </a:r>
             <a:endParaRPr lang="en-US" sz="3200" dirty="0"/>
           </a:p>
@@ -9132,7 +9132,7 @@
                 <a:ea typeface="Calibri" pitchFamily="34" charset="-122"/>
                 <a:cs typeface="Calibri" pitchFamily="34" charset="-120"/>
               </a:rPr>
-              <a:t>of runs passed overall (104 of 140). Only 4 of 14 tasks passed every time.</a:t>
+              <a:t>of the time is now the model writing answers. Reading its instructions fell from 54% to 33%.</a:t>
             </a:r>
             <a:endParaRPr lang="en-US" sz="1200" dirty="0"/>
           </a:p>
@@ -9193,7 +9193,7 @@
                 <a:ea typeface="Cambria" pitchFamily="34" charset="-122"/>
                 <a:cs typeface="Cambria" pitchFamily="34" charset="-120"/>
               </a:rPr>
-              <a:t>1%</a:t>
+              <a:t>71%</a:t>
             </a:r>
             <a:endParaRPr lang="en-US" sz="3200" dirty="0"/>
           </a:p>
@@ -9232,7 +9232,7 @@
                 <a:ea typeface="Calibri" pitchFamily="34" charset="-122"/>
                 <a:cs typeface="Calibri" pitchFamily="34" charset="-120"/>
               </a:rPr>
-              <a:t>of the time is spent in tools. Faster tools would not help; shorter prompts might.</a:t>
+              <a:t>of runs passed overall (99 of 140). Only 4 of 14 tasks passed every time.</a:t>
             </a:r>
             <a:endParaRPr lang="en-US" sz="1200" dirty="0"/>
           </a:p>

</xml_diff>

<commit_message>
P1: verification-claim checker and baseline findings
</commit_message>
<xml_diff>
--- a/Doc/Agent_opt.pptx
+++ b/Doc/Agent_opt.pptx
@@ -116,26 +116,26 @@
   <p:extLst>
     <p:ext uri="{521415D9-36F7-43E2-AB2F-B90AF26B5E84}">
       <p14:sectionLst xmlns:p14="http://schemas.microsoft.com/office/powerpoint/2010/main">
-        <p14:section name="Purpose" id="{5ef119da-be18-3ab8-5110-a579815220dd}">
+        <p14:section name="Purpose" id="{2e14b406-0f11-3485-4f48-86c0f0e86b21}">
           <p14:sldIdLst>
             <p14:sldId id="256"/>
             <p14:sldId id="257"/>
             <p14:sldId id="258"/>
           </p14:sldIdLst>
         </p14:section>
-        <p14:section name="Method" id="{1529a4f8-cc56-f809-b822-1a52da11bd0f}">
+        <p14:section name="Method" id="{00f00e95-aae0-cff4-8031-90e13aed4e18}">
           <p14:sldIdLst>
             <p14:sldId id="259"/>
             <p14:sldId id="260"/>
           </p14:sldIdLst>
         </p14:section>
-        <p14:section name="Status" id="{1f235bdf-0f94-5018-4c1b-f0d183177f49}">
+        <p14:section name="Status" id="{d7f4a559-53fd-d277-8dc5-5c57ba70e4b4}">
           <p14:sldIdLst>
             <p14:sldId id="261"/>
             <p14:sldId id="262"/>
           </p14:sldIdLst>
         </p14:section>
-        <p14:section name="Next" id="{e5331f51-c785-3da5-5f23-ac682e38d448}">
+        <p14:section name="Next" id="{7ab3da69-eab3-5381-f7c8-7f482133f418}">
           <p14:sldIdLst>
             <p14:sldId id="263"/>
             <p14:sldId id="264"/>
@@ -3067,7 +3067,7 @@
                 <a:ea typeface="Cambria" pitchFamily="34" charset="-122"/>
                 <a:cs typeface="Cambria" pitchFamily="34" charset="-120"/>
               </a:rPr>
-              <a:t>289</a:t>
+              <a:t>311</a:t>
             </a:r>
             <a:endParaRPr lang="en-US" sz="4400" dirty="0"/>
           </a:p>
@@ -7366,7 +7366,7 @@
                 <a:ea typeface="Calibri" pitchFamily="34" charset="-122"/>
                 <a:cs typeface="Calibri" pitchFamily="34" charset="-120"/>
               </a:rPr>
-              <a:t>289 automated tests; results are re-derived from recordings on every change.</a:t>
+              <a:t>311 automated tests; results are re-derived from recordings on every change.</a:t>
             </a:r>
             <a:endParaRPr lang="en-US" sz="1400" dirty="0"/>
           </a:p>

</xml_diff>

<commit_message>
P3: per-task trials, named suites, previous-trial covariate
</commit_message>
<xml_diff>
--- a/Doc/Agent_opt.pptx
+++ b/Doc/Agent_opt.pptx
@@ -116,26 +116,26 @@
   <p:extLst>
     <p:ext uri="{521415D9-36F7-43E2-AB2F-B90AF26B5E84}">
       <p14:sectionLst xmlns:p14="http://schemas.microsoft.com/office/powerpoint/2010/main">
-        <p14:section name="Purpose" id="{2e14b406-0f11-3485-4f48-86c0f0e86b21}">
+        <p14:section name="Purpose" id="{860900ed-a955-ea81-264c-34337368e1ea}">
           <p14:sldIdLst>
             <p14:sldId id="256"/>
             <p14:sldId id="257"/>
             <p14:sldId id="258"/>
           </p14:sldIdLst>
         </p14:section>
-        <p14:section name="Method" id="{00f00e95-aae0-cff4-8031-90e13aed4e18}">
+        <p14:section name="Method" id="{a22a24c3-03e4-38c6-e5fc-2a1c8dc423e9}">
           <p14:sldIdLst>
             <p14:sldId id="259"/>
             <p14:sldId id="260"/>
           </p14:sldIdLst>
         </p14:section>
-        <p14:section name="Status" id="{d7f4a559-53fd-d277-8dc5-5c57ba70e4b4}">
+        <p14:section name="Status" id="{438b894c-8733-3585-95b2-37cac619baac}">
           <p14:sldIdLst>
             <p14:sldId id="261"/>
             <p14:sldId id="262"/>
           </p14:sldIdLst>
         </p14:section>
-        <p14:section name="Next" id="{7ab3da69-eab3-5381-f7c8-7f482133f418}">
+        <p14:section name="Next" id="{7709384e-e7a8-8da0-2d7b-9c75c44db130}">
           <p14:sldIdLst>
             <p14:sldId id="263"/>
             <p14:sldId id="264"/>
@@ -3067,7 +3067,7 @@
                 <a:ea typeface="Cambria" pitchFamily="34" charset="-122"/>
                 <a:cs typeface="Cambria" pitchFamily="34" charset="-120"/>
               </a:rPr>
-              <a:t>311</a:t>
+              <a:t>324</a:t>
             </a:r>
             <a:endParaRPr lang="en-US" sz="4400" dirty="0"/>
           </a:p>
@@ -7366,7 +7366,7 @@
                 <a:ea typeface="Calibri" pitchFamily="34" charset="-122"/>
                 <a:cs typeface="Calibri" pitchFamily="34" charset="-120"/>
               </a:rPr>
-              <a:t>311 automated tests; results are re-derived from recordings on every change.</a:t>
+              <a:t>324 automated tests; results are re-derived from recordings on every change.</a:t>
             </a:r>
             <a:endParaRPr lang="en-US" sz="1400" dirty="0"/>
           </a:p>

</xml_diff>

<commit_message>
P7: proxy request capture, prompt replay tool, first replay probe
</commit_message>
<xml_diff>
--- a/Doc/Agent_opt.pptx
+++ b/Doc/Agent_opt.pptx
@@ -116,26 +116,26 @@
   <p:extLst>
     <p:ext uri="{521415D9-36F7-43E2-AB2F-B90AF26B5E84}">
       <p14:sectionLst xmlns:p14="http://schemas.microsoft.com/office/powerpoint/2010/main">
-        <p14:section name="Purpose" id="{860900ed-a955-ea81-264c-34337368e1ea}">
+        <p14:section name="Purpose" id="{ab67f6c6-29ea-25c3-4ae8-f81963c8de98}">
           <p14:sldIdLst>
             <p14:sldId id="256"/>
             <p14:sldId id="257"/>
             <p14:sldId id="258"/>
           </p14:sldIdLst>
         </p14:section>
-        <p14:section name="Method" id="{a22a24c3-03e4-38c6-e5fc-2a1c8dc423e9}">
+        <p14:section name="Method" id="{0b219d35-1408-a97c-6546-964ac76afa82}">
           <p14:sldIdLst>
             <p14:sldId id="259"/>
             <p14:sldId id="260"/>
           </p14:sldIdLst>
         </p14:section>
-        <p14:section name="Status" id="{438b894c-8733-3585-95b2-37cac619baac}">
+        <p14:section name="Status" id="{da3b61c5-c3ee-c4a9-69d4-adf745785028}">
           <p14:sldIdLst>
             <p14:sldId id="261"/>
             <p14:sldId id="262"/>
           </p14:sldIdLst>
         </p14:section>
-        <p14:section name="Next" id="{7709384e-e7a8-8da0-2d7b-9c75c44db130}">
+        <p14:section name="Next" id="{e346f83c-70a2-b0d7-182f-0c85ead21949}">
           <p14:sldIdLst>
             <p14:sldId id="263"/>
             <p14:sldId id="264"/>
@@ -3067,7 +3067,7 @@
                 <a:ea typeface="Cambria" pitchFamily="34" charset="-122"/>
                 <a:cs typeface="Cambria" pitchFamily="34" charset="-120"/>
               </a:rPr>
-              <a:t>324</a:t>
+              <a:t>335</a:t>
             </a:r>
             <a:endParaRPr lang="en-US" sz="4400" dirty="0"/>
           </a:p>
@@ -7366,7 +7366,7 @@
                 <a:ea typeface="Calibri" pitchFamily="34" charset="-122"/>
                 <a:cs typeface="Calibri" pitchFamily="34" charset="-120"/>
               </a:rPr>
-              <a:t>324 automated tests; results are re-derived from recordings on every change.</a:t>
+              <a:t>335 automated tests; results are re-derived from recordings on every change.</a:t>
             </a:r>
             <a:endParaRPr lang="en-US" sz="1400" dirty="0"/>
           </a:p>

</xml_diff>

<commit_message>
P4: per-config Ollama server settings, sweep configs, server survey
</commit_message>
<xml_diff>
--- a/Doc/Agent_opt.pptx
+++ b/Doc/Agent_opt.pptx
@@ -116,26 +116,26 @@
   <p:extLst>
     <p:ext uri="{521415D9-36F7-43E2-AB2F-B90AF26B5E84}">
       <p14:sectionLst xmlns:p14="http://schemas.microsoft.com/office/powerpoint/2010/main">
-        <p14:section name="Purpose" id="{ab67f6c6-29ea-25c3-4ae8-f81963c8de98}">
+        <p14:section name="Purpose" id="{c6bde8fb-8e72-a46f-9b7c-1447ba60bcaf}">
           <p14:sldIdLst>
             <p14:sldId id="256"/>
             <p14:sldId id="257"/>
             <p14:sldId id="258"/>
           </p14:sldIdLst>
         </p14:section>
-        <p14:section name="Method" id="{0b219d35-1408-a97c-6546-964ac76afa82}">
+        <p14:section name="Method" id="{1787ab2d-578c-0983-fb8b-3b1724165368}">
           <p14:sldIdLst>
             <p14:sldId id="259"/>
             <p14:sldId id="260"/>
           </p14:sldIdLst>
         </p14:section>
-        <p14:section name="Status" id="{da3b61c5-c3ee-c4a9-69d4-adf745785028}">
+        <p14:section name="Status" id="{24595783-c42d-383e-1cbc-dab59ff305a8}">
           <p14:sldIdLst>
             <p14:sldId id="261"/>
             <p14:sldId id="262"/>
           </p14:sldIdLst>
         </p14:section>
-        <p14:section name="Next" id="{e346f83c-70a2-b0d7-182f-0c85ead21949}">
+        <p14:section name="Next" id="{45a62d77-4b4d-32e9-0400-ef83980ac149}">
           <p14:sldIdLst>
             <p14:sldId id="263"/>
             <p14:sldId id="264"/>
@@ -3067,7 +3067,7 @@
                 <a:ea typeface="Cambria" pitchFamily="34" charset="-122"/>
                 <a:cs typeface="Cambria" pitchFamily="34" charset="-120"/>
               </a:rPr>
-              <a:t>335</a:t>
+              <a:t>350</a:t>
             </a:r>
             <a:endParaRPr lang="en-US" sz="4400" dirty="0"/>
           </a:p>
@@ -7366,7 +7366,7 @@
                 <a:ea typeface="Calibri" pitchFamily="34" charset="-122"/>
                 <a:cs typeface="Calibri" pitchFamily="34" charset="-120"/>
               </a:rPr>
-              <a:t>335 automated tests; results are re-derived from recordings on every change.</a:t>
+              <a:t>350 automated tests; results are re-derived from recordings on every change.</a:t>
             </a:r>
             <a:endParaRPr lang="en-US" sz="1400" dirty="0"/>
           </a:p>

</xml_diff>

<commit_message>
P9: vocabulary check, bundled llama-server findings, speculative-decoding smoke test
</commit_message>
<xml_diff>
--- a/Doc/Agent_opt.pptx
+++ b/Doc/Agent_opt.pptx
@@ -116,26 +116,26 @@
   <p:extLst>
     <p:ext uri="{521415D9-36F7-43E2-AB2F-B90AF26B5E84}">
       <p14:sectionLst xmlns:p14="http://schemas.microsoft.com/office/powerpoint/2010/main">
-        <p14:section name="Purpose" id="{c6bde8fb-8e72-a46f-9b7c-1447ba60bcaf}">
+        <p14:section name="Purpose" id="{2a83e0bb-c321-925f-97df-4b4284de963b}">
           <p14:sldIdLst>
             <p14:sldId id="256"/>
             <p14:sldId id="257"/>
             <p14:sldId id="258"/>
           </p14:sldIdLst>
         </p14:section>
-        <p14:section name="Method" id="{1787ab2d-578c-0983-fb8b-3b1724165368}">
+        <p14:section name="Method" id="{a63cdb60-b4ae-9baa-4c4c-dfb6c1c3837e}">
           <p14:sldIdLst>
             <p14:sldId id="259"/>
             <p14:sldId id="260"/>
           </p14:sldIdLst>
         </p14:section>
-        <p14:section name="Status" id="{24595783-c42d-383e-1cbc-dab59ff305a8}">
+        <p14:section name="Status" id="{3fc56b88-42c1-51a0-5c69-5b40c901e805}">
           <p14:sldIdLst>
             <p14:sldId id="261"/>
             <p14:sldId id="262"/>
           </p14:sldIdLst>
         </p14:section>
-        <p14:section name="Next" id="{45a62d77-4b4d-32e9-0400-ef83980ac149}">
+        <p14:section name="Next" id="{60437112-7099-3de0-3a03-ba75db9dbd28}">
           <p14:sldIdLst>
             <p14:sldId id="263"/>
             <p14:sldId id="264"/>
@@ -3067,7 +3067,7 @@
                 <a:ea typeface="Cambria" pitchFamily="34" charset="-122"/>
                 <a:cs typeface="Cambria" pitchFamily="34" charset="-120"/>
               </a:rPr>
-              <a:t>350</a:t>
+              <a:t>357</a:t>
             </a:r>
             <a:endParaRPr lang="en-US" sz="4400" dirty="0"/>
           </a:p>
@@ -7366,7 +7366,7 @@
                 <a:ea typeface="Calibri" pitchFamily="34" charset="-122"/>
                 <a:cs typeface="Calibri" pitchFamily="34" charset="-120"/>
               </a:rPr>
-              <a:t>350 automated tests; results are re-derived from recordings on every change.</a:t>
+              <a:t>357 automated tests; results are re-derived from recordings on every change.</a:t>
             </a:r>
             <a:endParaRPr lang="en-US" sz="1400" dirty="0"/>
           </a:p>
@@ -9794,7 +9794,7 @@
                 <a:ea typeface="Calibri" pitchFamily="34" charset="-122"/>
                 <a:cs typeface="Calibri" pitchFamily="34" charset="-120"/>
               </a:rPr>
-              <a:t>Faster answering with a draft model</a:t>
+              <a:t>Faster answering (speculative decoding)</a:t>
             </a:r>
             <a:endParaRPr lang="en-US" sz="1400" dirty="0"/>
           </a:p>

</xml_diff>

<commit_message>
P5: four harder tasks with verifiers, golden cases and calibration
</commit_message>
<xml_diff>
--- a/Doc/Agent_opt.pptx
+++ b/Doc/Agent_opt.pptx
@@ -116,26 +116,26 @@
   <p:extLst>
     <p:ext uri="{521415D9-36F7-43E2-AB2F-B90AF26B5E84}">
       <p14:sectionLst xmlns:p14="http://schemas.microsoft.com/office/powerpoint/2010/main">
-        <p14:section name="Purpose" id="{2a83e0bb-c321-925f-97df-4b4284de963b}">
+        <p14:section name="Purpose" id="{c64bfb76-731b-8c14-50e8-9cb2d589cc35}">
           <p14:sldIdLst>
             <p14:sldId id="256"/>
             <p14:sldId id="257"/>
             <p14:sldId id="258"/>
           </p14:sldIdLst>
         </p14:section>
-        <p14:section name="Method" id="{a63cdb60-b4ae-9baa-4c4c-dfb6c1c3837e}">
+        <p14:section name="Method" id="{a00aaa9f-2b8a-6a02-6416-28d0e5437348}">
           <p14:sldIdLst>
             <p14:sldId id="259"/>
             <p14:sldId id="260"/>
           </p14:sldIdLst>
         </p14:section>
-        <p14:section name="Status" id="{3fc56b88-42c1-51a0-5c69-5b40c901e805}">
+        <p14:section name="Status" id="{4e59cf9a-6327-1467-5a05-e25111420189}">
           <p14:sldIdLst>
             <p14:sldId id="261"/>
             <p14:sldId id="262"/>
           </p14:sldIdLst>
         </p14:section>
-        <p14:section name="Next" id="{60437112-7099-3de0-3a03-ba75db9dbd28}">
+        <p14:section name="Next" id="{6071d16e-6507-38bd-687d-7d75b735703d}">
           <p14:sldIdLst>
             <p14:sldId id="263"/>
             <p14:sldId id="264"/>
@@ -2989,7 +2989,7 @@
                 <a:ea typeface="Cambria" pitchFamily="34" charset="-122"/>
                 <a:cs typeface="Cambria" pitchFamily="34" charset="-120"/>
               </a:rPr>
-              <a:t>14</a:t>
+              <a:t>18</a:t>
             </a:r>
             <a:endParaRPr lang="en-US" sz="4400" dirty="0"/>
           </a:p>
@@ -3067,7 +3067,7 @@
                 <a:ea typeface="Cambria" pitchFamily="34" charset="-122"/>
                 <a:cs typeface="Cambria" pitchFamily="34" charset="-120"/>
               </a:rPr>
-              <a:t>357</a:t>
+              <a:t>389</a:t>
             </a:r>
             <a:endParaRPr lang="en-US" sz="4400" dirty="0"/>
           </a:p>
@@ -3577,7 +3577,7 @@
                 <a:ea typeface="Calibri" pitchFamily="34" charset="-122"/>
                 <a:cs typeface="Calibri" pitchFamily="34" charset="-120"/>
               </a:rPr>
-              <a:t>Four of 14 tasks pass every time, so they cannot show an improvement; some may need to be made harder.</a:t>
+              <a:t>Four of the first 14 tasks passed every time, so four harder ones were added; they pass 30 to 60% of runs.</a:t>
             </a:r>
             <a:endParaRPr lang="en-US" sz="1400" dirty="0"/>
           </a:p>
@@ -5801,7 +5801,7 @@
                 <a:ea typeface="Calibri" pitchFamily="34" charset="-122"/>
                 <a:cs typeface="Calibri" pitchFamily="34" charset="-120"/>
               </a:rPr>
-              <a:t>14 realistic tasks, each with an automatic pass/fail check.</a:t>
+              <a:t>18 realistic tasks (4 added to be harder), each with an automatic pass/fail check.</a:t>
             </a:r>
             <a:endParaRPr lang="en-US" sz="1400" dirty="0"/>
           </a:p>
@@ -6790,7 +6790,7 @@
                 <a:ea typeface="Calibri" pitchFamily="34" charset="-122"/>
                 <a:cs typeface="Calibri" pitchFamily="34" charset="-120"/>
               </a:rPr>
-              <a:t>14 tasks are judged by code: compile and run, unit tests, fact checks.</a:t>
+              <a:t>18 tasks are judged by code: compile and run, unit tests, fact checks.</a:t>
             </a:r>
             <a:endParaRPr lang="en-US" sz="1400" dirty="0"/>
           </a:p>
@@ -7366,7 +7366,7 @@
                 <a:ea typeface="Calibri" pitchFamily="34" charset="-122"/>
                 <a:cs typeface="Calibri" pitchFamily="34" charset="-120"/>
               </a:rPr>
-              <a:t>357 automated tests; results are re-derived from recordings on every change.</a:t>
+              <a:t>389 automated tests; results are re-derived from recordings on every change.</a:t>
             </a:r>
             <a:endParaRPr lang="en-US" sz="1400" dirty="0"/>
           </a:p>
@@ -10417,7 +10417,7 @@
                 <a:ea typeface="Cambria" pitchFamily="34" charset="-122"/>
                 <a:cs typeface="Cambria" pitchFamily="34" charset="-120"/>
               </a:rPr>
-              <a:t>14 × 10 × 6</a:t>
+              <a:t>18 × 10 × 6</a:t>
             </a:r>
             <a:endParaRPr lang="en-US" sz="4400" dirty="0"/>
           </a:p>

</xml_diff>

<commit_message>
P2/P6 preparation: determinism analysis, qwen3:8b configs, session script
</commit_message>
<xml_diff>
--- a/Doc/Agent_opt.pptx
+++ b/Doc/Agent_opt.pptx
@@ -116,26 +116,26 @@
   <p:extLst>
     <p:ext uri="{521415D9-36F7-43E2-AB2F-B90AF26B5E84}">
       <p14:sectionLst xmlns:p14="http://schemas.microsoft.com/office/powerpoint/2010/main">
-        <p14:section name="Purpose" id="{c64bfb76-731b-8c14-50e8-9cb2d589cc35}">
+        <p14:section name="Purpose" id="{d286ca2a-8604-6db0-b895-3388893b2a6e}">
           <p14:sldIdLst>
             <p14:sldId id="256"/>
             <p14:sldId id="257"/>
             <p14:sldId id="258"/>
           </p14:sldIdLst>
         </p14:section>
-        <p14:section name="Method" id="{a00aaa9f-2b8a-6a02-6416-28d0e5437348}">
+        <p14:section name="Method" id="{5e65f424-afff-a6a1-6036-47cc1c6fb31a}">
           <p14:sldIdLst>
             <p14:sldId id="259"/>
             <p14:sldId id="260"/>
           </p14:sldIdLst>
         </p14:section>
-        <p14:section name="Status" id="{4e59cf9a-6327-1467-5a05-e25111420189}">
+        <p14:section name="Status" id="{4971dad1-c355-9e51-2998-17c6cb11fb85}">
           <p14:sldIdLst>
             <p14:sldId id="261"/>
             <p14:sldId id="262"/>
           </p14:sldIdLst>
         </p14:section>
-        <p14:section name="Next" id="{6071d16e-6507-38bd-687d-7d75b735703d}">
+        <p14:section name="Next" id="{cbf1681a-0103-4a51-bb2a-9d7b9c108693}">
           <p14:sldIdLst>
             <p14:sldId id="263"/>
             <p14:sldId id="264"/>
@@ -3067,7 +3067,7 @@
                 <a:ea typeface="Cambria" pitchFamily="34" charset="-122"/>
                 <a:cs typeface="Cambria" pitchFamily="34" charset="-120"/>
               </a:rPr>
-              <a:t>389</a:t>
+              <a:t>393</a:t>
             </a:r>
             <a:endParaRPr lang="en-US" sz="4400" dirty="0"/>
           </a:p>
@@ -7366,7 +7366,7 @@
                 <a:ea typeface="Calibri" pitchFamily="34" charset="-122"/>
                 <a:cs typeface="Calibri" pitchFamily="34" charset="-120"/>
               </a:rPr>
-              <a:t>389 automated tests; results are re-derived from recordings on every change.</a:t>
+              <a:t>393 automated tests; results are re-derived from recordings on every change.</a:t>
             </a:r>
             <a:endParaRPr lang="en-US" sz="1400" dirty="0"/>
           </a:p>

</xml_diff>

<commit_message>
Determinism test, qwen3:8b screen, Landlock confinement
</commit_message>
<xml_diff>
--- a/Doc/Agent_opt.pptx
+++ b/Doc/Agent_opt.pptx
@@ -116,26 +116,26 @@
   <p:extLst>
     <p:ext uri="{521415D9-36F7-43E2-AB2F-B90AF26B5E84}">
       <p14:sectionLst xmlns:p14="http://schemas.microsoft.com/office/powerpoint/2010/main">
-        <p14:section name="Purpose" id="{d286ca2a-8604-6db0-b895-3388893b2a6e}">
+        <p14:section name="Purpose" id="{0a5112ee-cc56-9e7c-e312-b637e39bb7b3}">
           <p14:sldIdLst>
             <p14:sldId id="256"/>
             <p14:sldId id="257"/>
             <p14:sldId id="258"/>
           </p14:sldIdLst>
         </p14:section>
-        <p14:section name="Method" id="{5e65f424-afff-a6a1-6036-47cc1c6fb31a}">
+        <p14:section name="Method" id="{c241702f-3fd6-96c6-ac36-2664be798c61}">
           <p14:sldIdLst>
             <p14:sldId id="259"/>
             <p14:sldId id="260"/>
           </p14:sldIdLst>
         </p14:section>
-        <p14:section name="Status" id="{4971dad1-c355-9e51-2998-17c6cb11fb85}">
+        <p14:section name="Status" id="{7e456ff4-c940-fd4c-27c1-a7611061e8a7}">
           <p14:sldIdLst>
             <p14:sldId id="261"/>
             <p14:sldId id="262"/>
           </p14:sldIdLst>
         </p14:section>
-        <p14:section name="Next" id="{cbf1681a-0103-4a51-bb2a-9d7b9c108693}">
+        <p14:section name="Next" id="{326b69c9-e75e-aef1-7941-53916705b07c}">
           <p14:sldIdLst>
             <p14:sldId id="263"/>
             <p14:sldId id="264"/>
@@ -3067,7 +3067,7 @@
                 <a:ea typeface="Cambria" pitchFamily="34" charset="-122"/>
                 <a:cs typeface="Cambria" pitchFamily="34" charset="-120"/>
               </a:rPr>
-              <a:t>393</a:t>
+              <a:t>399</a:t>
             </a:r>
             <a:endParaRPr lang="en-US" sz="4400" dirty="0"/>
           </a:p>
@@ -7366,7 +7366,7 @@
                 <a:ea typeface="Calibri" pitchFamily="34" charset="-122"/>
                 <a:cs typeface="Calibri" pitchFamily="34" charset="-120"/>
               </a:rPr>
-              <a:t>393 automated tests; results are re-derived from recordings on every change.</a:t>
+              <a:t>399 automated tests; results are re-derived from recordings on every change.</a:t>
             </a:r>
             <a:endParaRPr lang="en-US" sz="1400" dirty="0"/>
           </a:p>

</xml_diff>

<commit_message>
M4.2: 16k vs 32k results
includes prompt-cache temp-dir fix and M4.2 run scripts
</commit_message>
<xml_diff>
--- a/Doc/Agent_opt.pptx
+++ b/Doc/Agent_opt.pptx
@@ -116,26 +116,26 @@
   <p:extLst>
     <p:ext uri="{521415D9-36F7-43E2-AB2F-B90AF26B5E84}">
       <p14:sectionLst xmlns:p14="http://schemas.microsoft.com/office/powerpoint/2010/main">
-        <p14:section name="Purpose" id="{0a5112ee-cc56-9e7c-e312-b637e39bb7b3}">
+        <p14:section name="Purpose" id="{010af589-8ff0-7071-07ef-4071d540fff6}">
           <p14:sldIdLst>
             <p14:sldId id="256"/>
             <p14:sldId id="257"/>
             <p14:sldId id="258"/>
           </p14:sldIdLst>
         </p14:section>
-        <p14:section name="Method" id="{c241702f-3fd6-96c6-ac36-2664be798c61}">
+        <p14:section name="Method" id="{fc89a5b2-82f3-b038-3296-79f4a922a30f}">
           <p14:sldIdLst>
             <p14:sldId id="259"/>
             <p14:sldId id="260"/>
           </p14:sldIdLst>
         </p14:section>
-        <p14:section name="Status" id="{7e456ff4-c940-fd4c-27c1-a7611061e8a7}">
+        <p14:section name="Status" id="{8133ab6e-9933-db7f-7d3d-0dec839970f1}">
           <p14:sldIdLst>
             <p14:sldId id="261"/>
             <p14:sldId id="262"/>
           </p14:sldIdLst>
         </p14:section>
-        <p14:section name="Next" id="{326b69c9-e75e-aef1-7941-53916705b07c}">
+        <p14:section name="Next" id="{88746a39-4f87-0d4f-d89a-70a4f5bc71c6}">
           <p14:sldIdLst>
             <p14:sldId id="263"/>
             <p14:sldId id="264"/>
@@ -3067,7 +3067,7 @@
                 <a:ea typeface="Cambria" pitchFamily="34" charset="-122"/>
                 <a:cs typeface="Cambria" pitchFamily="34" charset="-120"/>
               </a:rPr>
-              <a:t>399</a:t>
+              <a:t>403</a:t>
             </a:r>
             <a:endParaRPr lang="en-US" sz="4400" dirty="0"/>
           </a:p>
@@ -7366,7 +7366,7 @@
                 <a:ea typeface="Calibri" pitchFamily="34" charset="-122"/>
                 <a:cs typeface="Calibri" pitchFamily="34" charset="-120"/>
               </a:rPr>
-              <a:t>399 automated tests; results are re-derived from recordings on every change.</a:t>
+              <a:t>403 automated tests; results are re-derived from recordings on every change.</a:t>
             </a:r>
             <a:endParaRPr lang="en-US" sz="1400" dirty="0"/>
           </a:p>
@@ -8669,7 +8669,7 @@
                 <a:ea typeface="Cambria" pitchFamily="34" charset="-122"/>
                 <a:cs typeface="Cambria" pitchFamily="34" charset="-120"/>
               </a:rPr>
-              <a:t>M4.1 done, M4.2 next</a:t>
+              <a:t>M4.1 and M4.2 done</a:t>
             </a:r>
             <a:endParaRPr lang="en-US" sz="1800" dirty="0"/>
           </a:p>
@@ -8708,7 +8708,7 @@
                 <a:ea typeface="Calibri" pitchFamily="34" charset="-122"/>
                 <a:cs typeface="Calibri" pitchFamily="34" charset="-120"/>
               </a:rPr>
-              <a:t>The whole suite ran 10 times per task, twice (336 runs). Removing a leaked block from the prompt made runs about 42% faster. Next: repeat with a smaller memory window (16k).</a:t>
+              <a:t>Baselines: 336 runs; removing a leaked prompt block made runs about 42% faster. Smaller memory window (16k): no overall loss, but long-context tasks break.</a:t>
             </a:r>
             <a:endParaRPr lang="en-US" sz="1400" dirty="0"/>
           </a:p>
@@ -9485,7 +9485,7 @@
                 <a:ea typeface="Calibri" pitchFamily="34" charset="-122"/>
                 <a:cs typeface="Calibri" pitchFamily="34" charset="-120"/>
               </a:rPr>
-              <a:t>first run done; 16k run about 5 hours</a:t>
+              <a:t>baselines and 16k check done</a:t>
             </a:r>
             <a:endParaRPr lang="en-US" sz="1400" dirty="0"/>
           </a:p>
@@ -9549,7 +9549,7 @@
                 <a:ea typeface="Calibri" pitchFamily="34" charset="-122"/>
                 <a:cs typeface="Calibri" pitchFamily="34" charset="-120"/>
               </a:rPr>
-              <a:t>Next: re-check the earlier 16k vs 32k finding</a:t>
+              <a:t>Done: 16k vs 32k re-checked (breaks on long contexts)</a:t>
             </a:r>
             <a:endParaRPr lang="en-US" sz="1400" dirty="0"/>
           </a:p>

</xml_diff>

<commit_message>
M4.3: Nsight captures per task category, GPU-active share, run script
</commit_message>
<xml_diff>
--- a/Doc/Agent_opt.pptx
+++ b/Doc/Agent_opt.pptx
@@ -116,26 +116,26 @@
   <p:extLst>
     <p:ext uri="{521415D9-36F7-43E2-AB2F-B90AF26B5E84}">
       <p14:sectionLst xmlns:p14="http://schemas.microsoft.com/office/powerpoint/2010/main">
-        <p14:section name="Purpose" id="{010af589-8ff0-7071-07ef-4071d540fff6}">
+        <p14:section name="Purpose" id="{5f484f62-7299-7ea3-71f9-e7455c8f92b2}">
           <p14:sldIdLst>
             <p14:sldId id="256"/>
             <p14:sldId id="257"/>
             <p14:sldId id="258"/>
           </p14:sldIdLst>
         </p14:section>
-        <p14:section name="Method" id="{fc89a5b2-82f3-b038-3296-79f4a922a30f}">
+        <p14:section name="Method" id="{7d6d861f-5a71-20ac-ee10-cc8d6101f7aa}">
           <p14:sldIdLst>
             <p14:sldId id="259"/>
             <p14:sldId id="260"/>
           </p14:sldIdLst>
         </p14:section>
-        <p14:section name="Status" id="{8133ab6e-9933-db7f-7d3d-0dec839970f1}">
+        <p14:section name="Status" id="{48f76618-eae7-cd1b-1b94-5705722975c5}">
           <p14:sldIdLst>
             <p14:sldId id="261"/>
             <p14:sldId id="262"/>
           </p14:sldIdLst>
         </p14:section>
-        <p14:section name="Next" id="{88746a39-4f87-0d4f-d89a-70a4f5bc71c6}">
+        <p14:section name="Next" id="{e8b1edb8-fdea-5489-f1ee-4292ab759fc5}">
           <p14:sldIdLst>
             <p14:sldId id="263"/>
             <p14:sldId id="264"/>
@@ -3067,7 +3067,7 @@
                 <a:ea typeface="Cambria" pitchFamily="34" charset="-122"/>
                 <a:cs typeface="Cambria" pitchFamily="34" charset="-120"/>
               </a:rPr>
-              <a:t>403</a:t>
+              <a:t>407</a:t>
             </a:r>
             <a:endParaRPr lang="en-US" sz="4400" dirty="0"/>
           </a:p>
@@ -7366,7 +7366,7 @@
                 <a:ea typeface="Calibri" pitchFamily="34" charset="-122"/>
                 <a:cs typeface="Calibri" pitchFamily="34" charset="-120"/>
               </a:rPr>
-              <a:t>403 automated tests; results are re-derived from recordings on every change.</a:t>
+              <a:t>407 automated tests; results are re-derived from recordings on every change.</a:t>
             </a:r>
             <a:endParaRPr lang="en-US" sz="1400" dirty="0"/>
           </a:p>
@@ -8669,7 +8669,7 @@
                 <a:ea typeface="Cambria" pitchFamily="34" charset="-122"/>
                 <a:cs typeface="Cambria" pitchFamily="34" charset="-120"/>
               </a:rPr>
-              <a:t>M4.1 and M4.2 done</a:t>
+              <a:t>Milestone M4 done</a:t>
             </a:r>
             <a:endParaRPr lang="en-US" sz="1800" dirty="0"/>
           </a:p>
@@ -8708,7 +8708,7 @@
                 <a:ea typeface="Calibri" pitchFamily="34" charset="-122"/>
                 <a:cs typeface="Calibri" pitchFamily="34" charset="-120"/>
               </a:rPr>
-              <a:t>Baselines: 336 runs; removing a leaked prompt block made runs about 42% faster. Smaller memory window (16k): no overall loss, but long-context tasks break.</a:t>
+              <a:t>Baselines: 336 runs; removing a leaked prompt block made runs about 42% faster. 16k window: no overall loss, long contexts break. The GPU works only 12% of the time.</a:t>
             </a:r>
             <a:endParaRPr lang="en-US" sz="1400" dirty="0"/>
           </a:p>
@@ -9132,7 +9132,7 @@
                 <a:ea typeface="Calibri" pitchFamily="34" charset="-122"/>
                 <a:cs typeface="Calibri" pitchFamily="34" charset="-120"/>
               </a:rPr>
-              <a:t>of the time is now the model writing answers. Reading its instructions fell from 54% to 33%.</a:t>
+              <a:t>of the time is the model writing answers, yet the graphics card itself works only 12% of the time: the processor is the bottleneck.</a:t>
             </a:r>
             <a:endParaRPr lang="en-US" sz="1200" dirty="0"/>
           </a:p>
@@ -9485,7 +9485,7 @@
                 <a:ea typeface="Calibri" pitchFamily="34" charset="-122"/>
                 <a:cs typeface="Calibri" pitchFamily="34" charset="-120"/>
               </a:rPr>
-              <a:t>baselines and 16k check done</a:t>
+              <a:t>all measurements done</a:t>
             </a:r>
             <a:endParaRPr lang="en-US" sz="1400" dirty="0"/>
           </a:p>
@@ -9549,7 +9549,7 @@
                 <a:ea typeface="Calibri" pitchFamily="34" charset="-122"/>
                 <a:cs typeface="Calibri" pitchFamily="34" charset="-120"/>
               </a:rPr>
-              <a:t>Done: 16k vs 32k re-checked (breaks on long contexts)</a:t>
+              <a:t>Done: 16k vs 32k re-checked; GPU busy only 12% of the time</a:t>
             </a:r>
             <a:endParaRPr lang="en-US" sz="1400" dirty="0"/>
           </a:p>

</xml_diff>

<commit_message>
M5.3 speculative decoding sweep on replayed agent calls: no speed-up, output changes
</commit_message>
<xml_diff>
--- a/Doc/Agent_opt.pptx
+++ b/Doc/Agent_opt.pptx
@@ -116,26 +116,26 @@
   <p:extLst>
     <p:ext uri="{521415D9-36F7-43E2-AB2F-B90AF26B5E84}">
       <p14:sectionLst xmlns:p14="http://schemas.microsoft.com/office/powerpoint/2010/main">
-        <p14:section name="Purpose" id="{1832ca7d-c1c1-340e-7e3a-0223116566d6}">
+        <p14:section name="Purpose" id="{059c135c-7963-1e09-803a-db646bd3e202}">
           <p14:sldIdLst>
             <p14:sldId id="256"/>
             <p14:sldId id="257"/>
             <p14:sldId id="258"/>
           </p14:sldIdLst>
         </p14:section>
-        <p14:section name="Method" id="{df0af596-bd2d-057a-503d-d06b19ef80d8}">
+        <p14:section name="Method" id="{45229f94-8bdc-7f1b-994d-0b21aefbd190}">
           <p14:sldIdLst>
             <p14:sldId id="259"/>
             <p14:sldId id="260"/>
           </p14:sldIdLst>
         </p14:section>
-        <p14:section name="Status" id="{4534f24c-bc72-ec41-f12f-1784b663ba60}">
+        <p14:section name="Status" id="{1d5f8d1f-6012-7fd1-a13e-c96361fe7a64}">
           <p14:sldIdLst>
             <p14:sldId id="261"/>
             <p14:sldId id="262"/>
           </p14:sldIdLst>
         </p14:section>
-        <p14:section name="Next" id="{03dbd39a-0623-dfa4-8d44-12d3bb5e0cb5}">
+        <p14:section name="Next" id="{07d0c72e-622c-3e86-d058-41cfdf7e5d67}">
           <p14:sldIdLst>
             <p14:sldId id="263"/>
             <p14:sldId id="264"/>
@@ -3067,7 +3067,7 @@
                 <a:ea typeface="Cambria" pitchFamily="34" charset="-122"/>
                 <a:cs typeface="Cambria" pitchFamily="34" charset="-120"/>
               </a:rPr>
-              <a:t>408</a:t>
+              <a:t>414</a:t>
             </a:r>
             <a:endParaRPr lang="en-US" sz="4400" dirty="0"/>
           </a:p>
@@ -7366,7 +7366,7 @@
                 <a:ea typeface="Calibri" pitchFamily="34" charset="-122"/>
                 <a:cs typeface="Calibri" pitchFamily="34" charset="-120"/>
               </a:rPr>
-              <a:t>408 automated tests; results are re-derived from recordings on every change.</a:t>
+              <a:t>414 automated tests; results are re-derived from recordings on every change.</a:t>
             </a:r>
             <a:endParaRPr lang="en-US" sz="1400" dirty="0"/>
           </a:p>

</xml_diff>

<commit_message>
H6 agent-config screen: verification-step coding agent vs short-prompt control; agents: config key
</commit_message>
<xml_diff>
--- a/Doc/Agent_opt.pptx
+++ b/Doc/Agent_opt.pptx
@@ -116,26 +116,26 @@
   <p:extLst>
     <p:ext uri="{521415D9-36F7-43E2-AB2F-B90AF26B5E84}">
       <p14:sectionLst xmlns:p14="http://schemas.microsoft.com/office/powerpoint/2010/main">
-        <p14:section name="Purpose" id="{059c135c-7963-1e09-803a-db646bd3e202}">
+        <p14:section name="Purpose" id="{13ee2df6-293a-1f4f-74ab-ed59e71681d6}">
           <p14:sldIdLst>
             <p14:sldId id="256"/>
             <p14:sldId id="257"/>
             <p14:sldId id="258"/>
           </p14:sldIdLst>
         </p14:section>
-        <p14:section name="Method" id="{45229f94-8bdc-7f1b-994d-0b21aefbd190}">
+        <p14:section name="Method" id="{ca54b699-1f33-5666-f90b-ac32e2745711}">
           <p14:sldIdLst>
             <p14:sldId id="259"/>
             <p14:sldId id="260"/>
           </p14:sldIdLst>
         </p14:section>
-        <p14:section name="Status" id="{1d5f8d1f-6012-7fd1-a13e-c96361fe7a64}">
+        <p14:section name="Status" id="{c9d762c3-03a3-f1fe-e407-28ff337af3b5}">
           <p14:sldIdLst>
             <p14:sldId id="261"/>
             <p14:sldId id="262"/>
           </p14:sldIdLst>
         </p14:section>
-        <p14:section name="Next" id="{07d0c72e-622c-3e86-d058-41cfdf7e5d67}">
+        <p14:section name="Next" id="{46672b19-bcee-e46c-55c6-7dbced7c59ee}">
           <p14:sldIdLst>
             <p14:sldId id="263"/>
             <p14:sldId id="264"/>
@@ -3067,7 +3067,7 @@
                 <a:ea typeface="Cambria" pitchFamily="34" charset="-122"/>
                 <a:cs typeface="Cambria" pitchFamily="34" charset="-120"/>
               </a:rPr>
-              <a:t>414</a:t>
+              <a:t>416</a:t>
             </a:r>
             <a:endParaRPr lang="en-US" sz="4400" dirty="0"/>
           </a:p>
@@ -7366,7 +7366,7 @@
                 <a:ea typeface="Calibri" pitchFamily="34" charset="-122"/>
                 <a:cs typeface="Calibri" pitchFamily="34" charset="-120"/>
               </a:rPr>
-              <a:t>414 automated tests; results are re-derived from recordings on every change.</a:t>
+              <a:t>416 automated tests; results are re-derived from recordings on every change.</a:t>
             </a:r>
             <a:endParaRPr lang="en-US" sz="1400" dirty="0"/>
           </a:p>

</xml_diff>

<commit_message>
M7 documentation: results-first DIRECTION, slides
README restructured and v0 moved to docs
</commit_message>
<xml_diff>
--- a/Doc/Agent_opt.pptx
+++ b/Doc/Agent_opt.pptx
@@ -1416,7 +1416,7 @@
           <a:p>
             <a:r>
               <a:rPr lang="en-US" dirty="0"/>
-              <a:t>Agent_opt is a measurement project: it studies how a locally hosted AI coding agent behaves on a single mid-range graphics card (RTX 3080, 10 GB). The first four milestones built the measuring tools; the first full measurement run (168 runs) is done; the next steps use the tools for experiments. This deck explains why, how, where we are and what we need from you.</a:t>
+              <a:t>Agent_opt is a measurement project: it studies how a locally hosted AI coding agent behaves on a single mid-range graphics card (RTX 3080, 10 GB). The measuring tools, two full baselines, the lever experiments and the citation checker are done; the manual audit of flagged citations is the main open item. This deck explains why, how, what we found and what is left.</a:t>
             </a:r>
             <a:endParaRPr lang="en-US" dirty="0"/>
           </a:p>
@@ -1504,7 +1504,7 @@
           <a:p>
             <a:r>
               <a:rPr lang="en-US" dirty="0"/>
-              <a:t>The main ask is machine time: the statistically sound version of the experiments needs long unattended runs. The other two decisions are scoping choices that keep the project inside its planned effort.</a:t>
+              <a:t>The main open item is the manual citation audit, which turns the flagged-citation rate into an invented-citation rate. The other risks are limits of scope: one card, one model, small samples per lever.</a:t>
             </a:r>
             <a:endParaRPr lang="en-US" dirty="0"/>
           </a:p>
@@ -1944,7 +1944,7 @@
           <a:p>
             <a:r>
               <a:rPr lang="en-US" dirty="0"/>
-              <a:t>Eight milestones in total. The first four built and verified the measuring equipment; that part is finished and tested. The first full run (M4.1) is complete; the next steps compare settings against it.</a:t>
+              <a:t>Eight milestones in total. The first four built and verified the measuring equipment; M4 to M6 measured the baseline, tested the levers and built the citation checker. M7, the write-up, is under way.</a:t>
             </a:r>
             <a:endParaRPr lang="en-US" dirty="0"/>
           </a:p>
@@ -2120,7 +2120,7 @@
           <a:p>
             <a:r>
               <a:rPr lang="en-US" dirty="0"/>
-              <a:t>Roughly three more working weeks of effort, with long unattended GPU runs in M4 and M5. M4 is the immediate next step and is highlighted. The experiments in M5 are the heart of the project: each lever is tested against the baseline with confidence ranges.</a:t>
+              <a:t>Most levers were negative results, which is itself the finding: the card is mostly waiting for the processor, so settings that speed up the card do not help. What helped was the prompt: removing a leaked block and trimming unused tool descriptions.</a:t>
             </a:r>
             <a:endParaRPr lang="en-US" dirty="0"/>
           </a:p>
@@ -2208,7 +2208,7 @@
           <a:p>
             <a:r>
               <a:rPr lang="en-US" dirty="0"/>
-              <a:t>These are the plan's success criteria in plain language. The rule behind 'proven to help': the confidence range of the improvement must exclude zero and success rate must not drop by more than 5 percentage points.</a:t>
+              <a:t>The plan's success criteria in plain language, with their status. Two are met, three partly or not shown, one is done with this deck. Details are in the success-criteria tally in the plan.</a:t>
             </a:r>
             <a:endParaRPr lang="en-US" dirty="0"/>
           </a:p>
@@ -2928,7 +2928,7 @@
                 <a:ea typeface="Calibri" pitchFamily="34" charset="-122"/>
                 <a:cs typeface="Calibri" pitchFamily="34" charset="-120"/>
               </a:rPr>
-              <a:t>Project overview for project management. Status: tooling built (M0 to M3), first full baseline measured (M4.1).</a:t>
+              <a:t>Project overview. Status: experiments and citation checker done (M0 to M6); write-up (M7) under way.</a:t>
             </a:r>
             <a:endParaRPr lang="en-US" sz="1600" dirty="0"/>
           </a:p>
@@ -2989,7 +2989,7 @@
                 <a:ea typeface="Cambria" pitchFamily="34" charset="-122"/>
                 <a:cs typeface="Cambria" pitchFamily="34" charset="-120"/>
               </a:rPr>
-              <a:t>18</a:t>
+              <a:t>38</a:t>
             </a:r>
             <a:endParaRPr lang="en-US" sz="4400" dirty="0"/>
           </a:p>
@@ -3067,7 +3067,7 @@
                 <a:ea typeface="Cambria" pitchFamily="34" charset="-122"/>
                 <a:cs typeface="Cambria" pitchFamily="34" charset="-120"/>
               </a:rPr>
-              <a:t>416</a:t>
+              <a:t>428</a:t>
             </a:r>
             <a:endParaRPr lang="en-US" sz="4400" dirty="0"/>
           </a:p>
@@ -3145,7 +3145,7 @@
                 <a:ea typeface="Cambria" pitchFamily="34" charset="-122"/>
                 <a:cs typeface="Cambria" pitchFamily="34" charset="-120"/>
               </a:rPr>
-              <a:t>336</a:t>
+              <a:t>1,400</a:t>
             </a:r>
             <a:endParaRPr lang="en-US" sz="4400" dirty="0"/>
           </a:p>
@@ -3184,7 +3184,7 @@
                 <a:ea typeface="Calibri" pitchFamily="34" charset="-122"/>
                 <a:cs typeface="Calibri" pitchFamily="34" charset="-120"/>
               </a:rPr>
-              <a:t>baseline runs recorded in two full passes</a:t>
+              <a:t>trials recorded across baselines and experiments</a:t>
             </a:r>
             <a:endParaRPr lang="en-US" sz="1400" dirty="0"/>
           </a:p>
@@ -3250,7 +3250,7 @@
                 <a:ea typeface="Cambria" pitchFamily="34" charset="-122"/>
                 <a:cs typeface="Cambria" pitchFamily="34" charset="-120"/>
               </a:rPr>
-              <a:t>Risks and decisions we need</a:t>
+              <a:t>Risks and open items</a:t>
             </a:r>
             <a:endParaRPr lang="en-US" sz="3400" dirty="0"/>
           </a:p>
@@ -3394,7 +3394,7 @@
                 <a:ea typeface="Cambria" pitchFamily="34" charset="-122"/>
                 <a:cs typeface="Cambria" pitchFamily="34" charset="-120"/>
               </a:rPr>
-              <a:t>Machine time</a:t>
+              <a:t>Small samples</a:t>
             </a:r>
             <a:endParaRPr lang="en-US" sz="1600" dirty="0"/>
           </a:p>
@@ -3433,7 +3433,7 @@
                 <a:ea typeface="Calibri" pitchFamily="34" charset="-122"/>
                 <a:cs typeface="Calibri" pitchFamily="34" charset="-120"/>
               </a:rPr>
-              <a:t>10 repeats took about 4.3 hours for one setup; the full sweep is estimated at 25 hours of GPU time.</a:t>
+              <a:t>Most lever tests used 3 to 10 runs per task, so only large effects are visible.</a:t>
             </a:r>
             <a:endParaRPr lang="en-US" sz="1400" dirty="0"/>
           </a:p>
@@ -3538,7 +3538,7 @@
                 <a:ea typeface="Cambria" pitchFamily="34" charset="-122"/>
                 <a:cs typeface="Cambria" pitchFamily="34" charset="-120"/>
               </a:rPr>
-              <a:t>Too many easy tasks</a:t>
+              <a:t>Long runs</a:t>
             </a:r>
             <a:endParaRPr lang="en-US" sz="1600" dirty="0"/>
           </a:p>
@@ -3577,7 +3577,7 @@
                 <a:ea typeface="Calibri" pitchFamily="34" charset="-122"/>
                 <a:cs typeface="Calibri" pitchFamily="34" charset="-120"/>
               </a:rPr>
-              <a:t>Four of the first 14 tasks passed every time, so four harder ones were added; they pass 30 to 60% of runs.</a:t>
+              <a:t>Ten repeats of one setup take hours, so several levers were tested on a subset of tasks.</a:t>
             </a:r>
             <a:endParaRPr lang="en-US" sz="1400" dirty="0"/>
           </a:p>
@@ -3760,7 +3760,7 @@
                 <a:ea typeface="Cambria" pitchFamily="34" charset="-122"/>
                 <a:cs typeface="Cambria" pitchFamily="34" charset="-120"/>
               </a:rPr>
-              <a:t>Decisions needed</a:t>
+              <a:t>Open items</a:t>
             </a:r>
             <a:endParaRPr lang="en-US" sz="2200" dirty="0"/>
           </a:p>
@@ -3880,7 +3880,7 @@
                 <a:ea typeface="Cambria" pitchFamily="34" charset="-122"/>
                 <a:cs typeface="Cambria" pitchFamily="34" charset="-120"/>
               </a:rPr>
-              <a:t>Approve overnight GPU time</a:t>
+              <a:t>Label the citation audit</a:t>
             </a:r>
             <a:endParaRPr lang="en-US" sz="1600" dirty="0"/>
           </a:p>
@@ -3919,7 +3919,7 @@
                 <a:ea typeface="Calibri" pitchFamily="34" charset="-122"/>
                 <a:cs typeface="Calibri" pitchFamily="34" charset="-120"/>
               </a:rPr>
-              <a:t>About 40 hours of unattended runs spread over several nights.</a:t>
+              <a:t>117 citations to mark by hand; this gives the checker's accuracy and separates invented from unretrieved.</a:t>
             </a:r>
             <a:endParaRPr lang="en-US" sz="1400" dirty="0"/>
           </a:p>
@@ -4039,7 +4039,7 @@
                 <a:ea typeface="Cambria" pitchFamily="34" charset="-122"/>
                 <a:cs typeface="Cambria" pitchFamily="34" charset="-120"/>
               </a:rPr>
-              <a:t>Settle the sweep scope</a:t>
+              <a:t>Trimmed tool list</a:t>
             </a:r>
             <a:endParaRPr lang="en-US" sz="1600" dirty="0"/>
           </a:p>
@@ -4078,7 +4078,7 @@
                 <a:ea typeface="Calibri" pitchFamily="34" charset="-122"/>
                 <a:cs typeface="Calibri" pitchFamily="34" charset="-120"/>
               </a:rPr>
-              <a:t>If time runs short, drop in this order: second model, flash attention, 8k context.</a:t>
+              <a:t>The cold start is faster, but the effect on success is not measured yet.</a:t>
             </a:r>
             <a:endParaRPr lang="en-US" sz="1400" dirty="0"/>
           </a:p>
@@ -4198,7 +4198,7 @@
                 <a:ea typeface="Cambria" pitchFamily="34" charset="-122"/>
                 <a:cs typeface="Cambria" pitchFamily="34" charset="-120"/>
               </a:rPr>
-              <a:t>Handle the research task</a:t>
+              <a:t>Research window</a:t>
             </a:r>
             <a:endParaRPr lang="en-US" sz="1600" dirty="0"/>
           </a:p>
@@ -4237,7 +4237,7 @@
                 <a:ea typeface="Calibri" pitchFamily="34" charset="-122"/>
                 <a:cs typeface="Calibri" pitchFamily="34" charset="-120"/>
               </a:rPr>
-              <a:t>It passed only 1 of 10 runs at the baseline memory window and needs a larger one: keep it as a special case?</a:t>
+              <a:t>Research answers need a 64k window (most overflow at 32k): keep it as a special case.</a:t>
             </a:r>
             <a:endParaRPr lang="en-US" sz="1400" dirty="0"/>
           </a:p>
@@ -7624,7 +7624,7 @@
                 <a:ea typeface="Cambria" pitchFamily="34" charset="-122"/>
                 <a:cs typeface="Cambria" pitchFamily="34" charset="-120"/>
               </a:rPr>
-              <a:t>Where we are: tooling built, first data in</a:t>
+              <a:t>Where we are: experiments done</a:t>
             </a:r>
             <a:endParaRPr lang="en-US" sz="3400" dirty="0"/>
           </a:p>
@@ -7746,7 +7746,7 @@
                 <a:ea typeface="Calibri" pitchFamily="34" charset="-122"/>
                 <a:cs typeface="Calibri" pitchFamily="34" charset="-120"/>
               </a:rPr>
-              <a:t>Measurement phase: first run done</a:t>
+              <a:t>Measurement phase: done</a:t>
             </a:r>
             <a:endParaRPr lang="en-US" sz="1400" dirty="0"/>
           </a:p>
@@ -8109,7 +8109,7 @@
       </p:sp>
       <p:sp>
         <p:nvSpPr>
-          <p:cNvPr id="20" name="Milestone M4"/>
+          <p:cNvPr id="38" name="Milestone M4"/>
           <p:cNvSpPr/>
           <p:nvPr/>
         </p:nvSpPr>
@@ -8122,30 +8122,54 @@
             <a:avLst/>
           </a:prstGeom>
           <a:solidFill>
-            <a:schemeClr val="accent1"/>
+            <a:schemeClr val="accent2"/>
           </a:solidFill>
           <a:ln/>
         </p:spPr>
       </p:sp>
-      <p:sp>
-        <p:nvSpPr>
-          <p:cNvPr id="21" name="Milestone label M4"/>
+      <p:pic>
+        <p:nvPicPr>
+          <p:cNvPr id="39" name="Done check M4" descr="done">    </p:cNvPr>
+          <p:cNvPicPr>
+            <a:picLocks noChangeAspect="1"/>
+          </p:cNvPicPr>
+          <p:nvPr/>
+        </p:nvPicPr>
+        <p:blipFill>
+          <a:blip r:embed="rId4"/>
+          <a:stretch>
+            <a:fillRect/>
+          </a:stretch>
+        </p:blipFill>
+        <p:spPr>
+          <a:xfrm>
+            <a:off x="6606369" y="2468880"/>
+            <a:ext cx="365760" cy="365760"/>
+          </a:xfrm>
+          <a:prstGeom prst="rect">
+            <a:avLst/>
+          </a:prstGeom>
+        </p:spPr>
+      </p:pic>
+      <p:sp>
+        <p:nvSpPr>
+          <p:cNvPr id="22" name="Milestone name M4"/>
           <p:cNvSpPr txBox="1"/>
           <p:nvPr/>
         </p:nvSpPr>
         <p:spPr>
           <a:xfrm>
-            <a:off x="6469209" y="2331720"/>
-            <a:ext cx="640080" cy="640080"/>
-          </a:xfrm>
-          <a:prstGeom prst="rect">
-            <a:avLst/>
-          </a:prstGeom>
-          <a:noFill/>
-          <a:ln/>
-        </p:spPr>
-        <p:txBody>
-          <a:bodyPr wrap="square" lIns="0" tIns="0" rIns="0" bIns="0" rtlCol="0" anchor="ctr"/>
+            <a:off x="6141568" y="3108960"/>
+            <a:ext cx="1295362" cy="868680"/>
+          </a:xfrm>
+          <a:prstGeom prst="rect">
+            <a:avLst/>
+          </a:prstGeom>
+          <a:noFill/>
+          <a:ln/>
+        </p:spPr>
+        <p:txBody>
+          <a:bodyPr wrap="square" lIns="0" tIns="0" rIns="0" bIns="0" rtlCol="0" anchor="t"/>
           <a:lstStyle/>
           <a:p>
             <a:pPr algn="ctr" indent="0" marL="0">
@@ -8160,7 +8184,7 @@
                 <a:ea typeface="Calibri" pitchFamily="34" charset="-122"/>
                 <a:cs typeface="Calibri" pitchFamily="34" charset="-120"/>
               </a:rPr>
-              <a:t>M4</a:t>
+              <a:t>M4  Baseline campaign</a:t>
             </a:r>
             <a:endParaRPr lang="en-US" sz="1400" dirty="0"/>
           </a:p>
@@ -8168,13 +8192,57 @@
       </p:sp>
       <p:sp>
         <p:nvSpPr>
-          <p:cNvPr id="22" name="Milestone name M4"/>
+          <p:cNvPr id="40" name="Milestone M5"/>
+          <p:cNvSpPr/>
+          <p:nvPr/>
+        </p:nvSpPr>
+        <p:spPr>
+          <a:xfrm>
+            <a:off x="7856010" y="2331720"/>
+            <a:ext cx="640080" cy="640080"/>
+          </a:xfrm>
+          <a:prstGeom prst="ellipse">
+            <a:avLst/>
+          </a:prstGeom>
+          <a:solidFill>
+            <a:schemeClr val="accent2"/>
+          </a:solidFill>
+          <a:ln/>
+        </p:spPr>
+      </p:sp>
+      <p:pic>
+        <p:nvPicPr>
+          <p:cNvPr id="41" name="Done check M5" descr="done">    </p:cNvPr>
+          <p:cNvPicPr>
+            <a:picLocks noChangeAspect="1"/>
+          </p:cNvPicPr>
+          <p:nvPr/>
+        </p:nvPicPr>
+        <p:blipFill>
+          <a:blip r:embed="rId4"/>
+          <a:stretch>
+            <a:fillRect/>
+          </a:stretch>
+        </p:blipFill>
+        <p:spPr>
+          <a:xfrm>
+            <a:off x="7993170" y="2468880"/>
+            <a:ext cx="365760" cy="365760"/>
+          </a:xfrm>
+          <a:prstGeom prst="rect">
+            <a:avLst/>
+          </a:prstGeom>
+        </p:spPr>
+      </p:pic>
+      <p:sp>
+        <p:nvSpPr>
+          <p:cNvPr id="25" name="Milestone name M5"/>
           <p:cNvSpPr txBox="1"/>
           <p:nvPr/>
         </p:nvSpPr>
         <p:spPr>
           <a:xfrm>
-            <a:off x="6141568" y="3108960"/>
+            <a:off x="7528370" y="3108960"/>
             <a:ext cx="1295362" cy="868680"/>
           </a:xfrm>
           <a:prstGeom prst="rect">
@@ -8199,7 +8267,7 @@
                 <a:ea typeface="Calibri" pitchFamily="34" charset="-122"/>
                 <a:cs typeface="Calibri" pitchFamily="34" charset="-120"/>
               </a:rPr>
-              <a:t>M4  Baseline campaign</a:t>
+              <a:t>M5  Experiments</a:t>
             </a:r>
             <a:endParaRPr lang="en-US" sz="1400" dirty="0"/>
           </a:p>
@@ -8207,13 +8275,96 @@
       </p:sp>
       <p:sp>
         <p:nvSpPr>
-          <p:cNvPr id="23" name="Milestone M5"/>
+          <p:cNvPr id="42" name="Milestone M6"/>
           <p:cNvSpPr/>
           <p:nvPr/>
         </p:nvSpPr>
         <p:spPr>
           <a:xfrm>
-            <a:off x="7856010" y="2331720"/>
+            <a:off x="9242812" y="2331720"/>
+            <a:ext cx="640080" cy="640080"/>
+          </a:xfrm>
+          <a:prstGeom prst="ellipse">
+            <a:avLst/>
+          </a:prstGeom>
+          <a:solidFill>
+            <a:schemeClr val="accent2"/>
+          </a:solidFill>
+          <a:ln/>
+        </p:spPr>
+      </p:sp>
+      <p:pic>
+        <p:nvPicPr>
+          <p:cNvPr id="43" name="Done check M6" descr="done">    </p:cNvPr>
+          <p:cNvPicPr>
+            <a:picLocks noChangeAspect="1"/>
+          </p:cNvPicPr>
+          <p:nvPr/>
+        </p:nvPicPr>
+        <p:blipFill>
+          <a:blip r:embed="rId4"/>
+          <a:stretch>
+            <a:fillRect/>
+          </a:stretch>
+        </p:blipFill>
+        <p:spPr>
+          <a:xfrm>
+            <a:off x="9379972" y="2468880"/>
+            <a:ext cx="365760" cy="365760"/>
+          </a:xfrm>
+          <a:prstGeom prst="rect">
+            <a:avLst/>
+          </a:prstGeom>
+        </p:spPr>
+      </p:pic>
+      <p:sp>
+        <p:nvSpPr>
+          <p:cNvPr id="28" name="Milestone name M6"/>
+          <p:cNvSpPr txBox="1"/>
+          <p:nvPr/>
+        </p:nvSpPr>
+        <p:spPr>
+          <a:xfrm>
+            <a:off x="8915171" y="3108960"/>
+            <a:ext cx="1295362" cy="868680"/>
+          </a:xfrm>
+          <a:prstGeom prst="rect">
+            <a:avLst/>
+          </a:prstGeom>
+          <a:noFill/>
+          <a:ln/>
+        </p:spPr>
+        <p:txBody>
+          <a:bodyPr wrap="square" lIns="0" tIns="0" rIns="0" bIns="0" rtlCol="0" anchor="t"/>
+          <a:lstStyle/>
+          <a:p>
+            <a:pPr algn="ctr" indent="0" marL="0">
+              <a:buNone/>
+            </a:pPr>
+            <a:r>
+              <a:rPr lang="en-US" sz="1400" b="1" dirty="0">
+                <a:solidFill>
+                  <a:schemeClr val="tx1"/>
+                </a:solidFill>
+                <a:latin typeface="Calibri" pitchFamily="34" charset="0"/>
+                <a:ea typeface="Calibri" pitchFamily="34" charset="-122"/>
+                <a:cs typeface="Calibri" pitchFamily="34" charset="-120"/>
+              </a:rPr>
+              <a:t>M6  Citation checker</a:t>
+            </a:r>
+            <a:endParaRPr lang="en-US" sz="1400" dirty="0"/>
+          </a:p>
+        </p:txBody>
+      </p:sp>
+      <p:sp>
+        <p:nvSpPr>
+          <p:cNvPr id="29" name="Milestone M7"/>
+          <p:cNvSpPr/>
+          <p:nvPr/>
+        </p:nvSpPr>
+        <p:spPr>
+          <a:xfrm>
+            <a:off x="10629614" y="2331720"/>
             <a:ext cx="640080" cy="640080"/>
           </a:xfrm>
           <a:prstGeom prst="ellipse">
@@ -8232,212 +8383,6 @@
       </p:sp>
       <p:sp>
         <p:nvSpPr>
-          <p:cNvPr id="24" name="Milestone label M5"/>
-          <p:cNvSpPr txBox="1"/>
-          <p:nvPr/>
-        </p:nvSpPr>
-        <p:spPr>
-          <a:xfrm>
-            <a:off x="7856010" y="2331720"/>
-            <a:ext cx="640080" cy="640080"/>
-          </a:xfrm>
-          <a:prstGeom prst="rect">
-            <a:avLst/>
-          </a:prstGeom>
-          <a:noFill/>
-          <a:ln/>
-        </p:spPr>
-        <p:txBody>
-          <a:bodyPr wrap="square" lIns="0" tIns="0" rIns="0" bIns="0" rtlCol="0" anchor="ctr"/>
-          <a:lstStyle/>
-          <a:p>
-            <a:pPr algn="ctr" indent="0" marL="0">
-              <a:buNone/>
-            </a:pPr>
-            <a:r>
-              <a:rPr lang="en-US" sz="1400" b="1" dirty="0">
-                <a:solidFill>
-                  <a:schemeClr val="accent3"/>
-                </a:solidFill>
-                <a:latin typeface="Calibri" pitchFamily="34" charset="0"/>
-                <a:ea typeface="Calibri" pitchFamily="34" charset="-122"/>
-                <a:cs typeface="Calibri" pitchFamily="34" charset="-120"/>
-              </a:rPr>
-              <a:t>M5</a:t>
-            </a:r>
-            <a:endParaRPr lang="en-US" sz="1400" dirty="0"/>
-          </a:p>
-        </p:txBody>
-      </p:sp>
-      <p:sp>
-        <p:nvSpPr>
-          <p:cNvPr id="25" name="Milestone name M5"/>
-          <p:cNvSpPr txBox="1"/>
-          <p:nvPr/>
-        </p:nvSpPr>
-        <p:spPr>
-          <a:xfrm>
-            <a:off x="7528370" y="3108960"/>
-            <a:ext cx="1295362" cy="868680"/>
-          </a:xfrm>
-          <a:prstGeom prst="rect">
-            <a:avLst/>
-          </a:prstGeom>
-          <a:noFill/>
-          <a:ln/>
-        </p:spPr>
-        <p:txBody>
-          <a:bodyPr wrap="square" lIns="0" tIns="0" rIns="0" bIns="0" rtlCol="0" anchor="t"/>
-          <a:lstStyle/>
-          <a:p>
-            <a:pPr algn="ctr" indent="0" marL="0">
-              <a:buNone/>
-            </a:pPr>
-            <a:r>
-              <a:rPr lang="en-US" sz="1400" b="1" dirty="0">
-                <a:solidFill>
-                  <a:schemeClr val="tx1"/>
-                </a:solidFill>
-                <a:latin typeface="Calibri" pitchFamily="34" charset="0"/>
-                <a:ea typeface="Calibri" pitchFamily="34" charset="-122"/>
-                <a:cs typeface="Calibri" pitchFamily="34" charset="-120"/>
-              </a:rPr>
-              <a:t>M5  Experiments</a:t>
-            </a:r>
-            <a:endParaRPr lang="en-US" sz="1400" dirty="0"/>
-          </a:p>
-        </p:txBody>
-      </p:sp>
-      <p:sp>
-        <p:nvSpPr>
-          <p:cNvPr id="26" name="Milestone M6"/>
-          <p:cNvSpPr/>
-          <p:nvPr/>
-        </p:nvSpPr>
-        <p:spPr>
-          <a:xfrm>
-            <a:off x="9242812" y="2331720"/>
-            <a:ext cx="640080" cy="640080"/>
-          </a:xfrm>
-          <a:prstGeom prst="ellipse">
-            <a:avLst/>
-          </a:prstGeom>
-          <a:solidFill>
-            <a:srgbClr val="FFFFFF"/>
-          </a:solidFill>
-          <a:ln w="25400">
-            <a:solidFill>
-              <a:srgbClr val="9AA7AF"/>
-            </a:solidFill>
-            <a:prstDash val="solid"/>
-          </a:ln>
-        </p:spPr>
-      </p:sp>
-      <p:sp>
-        <p:nvSpPr>
-          <p:cNvPr id="27" name="Milestone label M6"/>
-          <p:cNvSpPr txBox="1"/>
-          <p:nvPr/>
-        </p:nvSpPr>
-        <p:spPr>
-          <a:xfrm>
-            <a:off x="9242812" y="2331720"/>
-            <a:ext cx="640080" cy="640080"/>
-          </a:xfrm>
-          <a:prstGeom prst="rect">
-            <a:avLst/>
-          </a:prstGeom>
-          <a:noFill/>
-          <a:ln/>
-        </p:spPr>
-        <p:txBody>
-          <a:bodyPr wrap="square" lIns="0" tIns="0" rIns="0" bIns="0" rtlCol="0" anchor="ctr"/>
-          <a:lstStyle/>
-          <a:p>
-            <a:pPr algn="ctr" indent="0" marL="0">
-              <a:buNone/>
-            </a:pPr>
-            <a:r>
-              <a:rPr lang="en-US" sz="1400" b="1" dirty="0">
-                <a:solidFill>
-                  <a:schemeClr val="accent3"/>
-                </a:solidFill>
-                <a:latin typeface="Calibri" pitchFamily="34" charset="0"/>
-                <a:ea typeface="Calibri" pitchFamily="34" charset="-122"/>
-                <a:cs typeface="Calibri" pitchFamily="34" charset="-120"/>
-              </a:rPr>
-              <a:t>M6</a:t>
-            </a:r>
-            <a:endParaRPr lang="en-US" sz="1400" dirty="0"/>
-          </a:p>
-        </p:txBody>
-      </p:sp>
-      <p:sp>
-        <p:nvSpPr>
-          <p:cNvPr id="28" name="Milestone name M6"/>
-          <p:cNvSpPr txBox="1"/>
-          <p:nvPr/>
-        </p:nvSpPr>
-        <p:spPr>
-          <a:xfrm>
-            <a:off x="8915171" y="3108960"/>
-            <a:ext cx="1295362" cy="868680"/>
-          </a:xfrm>
-          <a:prstGeom prst="rect">
-            <a:avLst/>
-          </a:prstGeom>
-          <a:noFill/>
-          <a:ln/>
-        </p:spPr>
-        <p:txBody>
-          <a:bodyPr wrap="square" lIns="0" tIns="0" rIns="0" bIns="0" rtlCol="0" anchor="t"/>
-          <a:lstStyle/>
-          <a:p>
-            <a:pPr algn="ctr" indent="0" marL="0">
-              <a:buNone/>
-            </a:pPr>
-            <a:r>
-              <a:rPr lang="en-US" sz="1400" b="1" dirty="0">
-                <a:solidFill>
-                  <a:schemeClr val="tx1"/>
-                </a:solidFill>
-                <a:latin typeface="Calibri" pitchFamily="34" charset="0"/>
-                <a:ea typeface="Calibri" pitchFamily="34" charset="-122"/>
-                <a:cs typeface="Calibri" pitchFamily="34" charset="-120"/>
-              </a:rPr>
-              <a:t>M6  Citation checker</a:t>
-            </a:r>
-            <a:endParaRPr lang="en-US" sz="1400" dirty="0"/>
-          </a:p>
-        </p:txBody>
-      </p:sp>
-      <p:sp>
-        <p:nvSpPr>
-          <p:cNvPr id="29" name="Milestone M7"/>
-          <p:cNvSpPr/>
-          <p:nvPr/>
-        </p:nvSpPr>
-        <p:spPr>
-          <a:xfrm>
-            <a:off x="10629614" y="2331720"/>
-            <a:ext cx="640080" cy="640080"/>
-          </a:xfrm>
-          <a:prstGeom prst="ellipse">
-            <a:avLst/>
-          </a:prstGeom>
-          <a:solidFill>
-            <a:srgbClr val="FFFFFF"/>
-          </a:solidFill>
-          <a:ln w="25400">
-            <a:solidFill>
-              <a:srgbClr val="9AA7AF"/>
-            </a:solidFill>
-            <a:prstDash val="solid"/>
-          </a:ln>
-        </p:spPr>
-      </p:sp>
-      <p:sp>
-        <p:nvSpPr>
           <p:cNvPr id="30" name="Milestone label M7"/>
           <p:cNvSpPr txBox="1"/>
           <p:nvPr/>
@@ -8669,7 +8614,7 @@
                 <a:ea typeface="Cambria" pitchFamily="34" charset="-122"/>
                 <a:cs typeface="Cambria" pitchFamily="34" charset="-120"/>
               </a:rPr>
-              <a:t>Milestone M4 done</a:t>
+              <a:t>Milestones M4 to M6 done</a:t>
             </a:r>
             <a:endParaRPr lang="en-US" sz="1800" dirty="0"/>
           </a:p>
@@ -8708,7 +8653,7 @@
                 <a:ea typeface="Calibri" pitchFamily="34" charset="-122"/>
                 <a:cs typeface="Calibri" pitchFamily="34" charset="-120"/>
               </a:rPr>
-              <a:t>Baselines: 336 runs; removing a leaked prompt block made runs about 42% faster. 16k window: no overall loss, long contexts break. The GPU works only 12% of the time.</a:t>
+              <a:t>A leaked prompt block cost 42% of run time; the GPU works only 12% of the time. Speculation, temperature, a smaller model and extra agent prompts gave no gain. 28% of cited sources were not backed by what the agent read.</a:t>
             </a:r>
             <a:endParaRPr lang="en-US" sz="1400" dirty="0"/>
           </a:p>
@@ -9346,7 +9291,7 @@
                 <a:ea typeface="Cambria" pitchFamily="34" charset="-122"/>
                 <a:cs typeface="Cambria" pitchFamily="34" charset="-120"/>
               </a:rPr>
-              <a:t>What happens next</a:t>
+              <a:t>What the experiments found</a:t>
             </a:r>
             <a:endParaRPr lang="en-US" sz="3400" dirty="0"/>
           </a:p>
@@ -9485,7 +9430,7 @@
                 <a:ea typeface="Calibri" pitchFamily="34" charset="-122"/>
                 <a:cs typeface="Calibri" pitchFamily="34" charset="-120"/>
               </a:rPr>
-              <a:t>all measurements done</a:t>
+              <a:t>done</a:t>
             </a:r>
             <a:endParaRPr lang="en-US" sz="1400" dirty="0"/>
           </a:p>
@@ -9709,7 +9654,7 @@
                 <a:ea typeface="Calibri" pitchFamily="34" charset="-122"/>
                 <a:cs typeface="Calibri" pitchFamily="34" charset="-120"/>
               </a:rPr>
-              <a:t>7 to 8 days</a:t>
+              <a:t>done</a:t>
             </a:r>
             <a:endParaRPr lang="en-US" sz="1400" dirty="0"/>
           </a:p>
@@ -9752,7 +9697,7 @@
                 <a:ea typeface="Calibri" pitchFamily="34" charset="-122"/>
                 <a:cs typeface="Calibri" pitchFamily="34" charset="-120"/>
               </a:rPr>
-              <a:t>Memory size of the context window</a:t>
+              <a:t>Leaked prompt removed: 42% faster</a:t>
             </a:r>
             <a:endParaRPr lang="en-US" sz="1400" dirty="0"/>
           </a:p>
@@ -9773,7 +9718,7 @@
                 <a:ea typeface="Calibri" pitchFamily="34" charset="-122"/>
                 <a:cs typeface="Calibri" pitchFamily="34" charset="-120"/>
               </a:rPr>
-              <a:t>Shorter agent instructions</a:t>
+              <a:t>Trimmed tools: cold start 26-34% faster</a:t>
             </a:r>
             <a:endParaRPr lang="en-US" sz="1400" dirty="0"/>
           </a:p>
@@ -9794,7 +9739,7 @@
                 <a:ea typeface="Calibri" pitchFamily="34" charset="-122"/>
                 <a:cs typeface="Calibri" pitchFamily="34" charset="-120"/>
               </a:rPr>
-              <a:t>Faster answering (speculative decoding)</a:t>
+              <a:t>Speculation, temperature, 8B: no gain</a:t>
             </a:r>
             <a:endParaRPr lang="en-US" sz="1400" dirty="0"/>
           </a:p>
@@ -9815,7 +9760,7 @@
                 <a:ea typeface="Calibri" pitchFamily="34" charset="-122"/>
                 <a:cs typeface="Calibri" pitchFamily="34" charset="-120"/>
               </a:rPr>
-              <a:t>A second model, task-specific agents</a:t>
+              <a:t>Agent prompts: no gain</a:t>
             </a:r>
             <a:endParaRPr lang="en-US" sz="1400" dirty="0"/>
           </a:p>
@@ -9954,7 +9899,7 @@
                 <a:ea typeface="Calibri" pitchFamily="34" charset="-122"/>
                 <a:cs typeface="Calibri" pitchFamily="34" charset="-120"/>
               </a:rPr>
-              <a:t>4 to 5 days</a:t>
+              <a:t>done</a:t>
             </a:r>
             <a:endParaRPr lang="en-US" sz="1400" dirty="0"/>
           </a:p>
@@ -9997,7 +9942,7 @@
                 <a:ea typeface="Calibri" pitchFamily="34" charset="-122"/>
                 <a:cs typeface="Calibri" pitchFamily="34" charset="-120"/>
               </a:rPr>
-              <a:t>Automatic check of every cited study</a:t>
+              <a:t>Every citation checked against what the agent read</a:t>
             </a:r>
             <a:endParaRPr lang="en-US" sz="1400" dirty="0"/>
           </a:p>
@@ -10018,7 +9963,7 @@
                 <a:ea typeface="Calibri" pitchFamily="34" charset="-122"/>
                 <a:cs typeface="Calibri" pitchFamily="34" charset="-120"/>
               </a:rPr>
-              <a:t>Measure invented citations before and after</a:t>
+              <a:t>28% not backed; dropping them keeps 99% of the text</a:t>
             </a:r>
             <a:endParaRPr lang="en-US" sz="1400" dirty="0"/>
           </a:p>
@@ -10157,7 +10102,7 @@
                 <a:ea typeface="Calibri" pitchFamily="34" charset="-122"/>
                 <a:cs typeface="Calibri" pitchFamily="34" charset="-120"/>
               </a:rPr>
-              <a:t>3 to 4 days</a:t>
+              <a:t>under way</a:t>
             </a:r>
             <a:endParaRPr lang="en-US" sz="1400" dirty="0"/>
           </a:p>
@@ -10221,7 +10166,7 @@
                 <a:ea typeface="Calibri" pitchFamily="34" charset="-122"/>
                 <a:cs typeface="Calibri" pitchFamily="34" charset="-120"/>
               </a:rPr>
-              <a:t>Slide deck</a:t>
+              <a:t>Slide deck updated</a:t>
             </a:r>
             <a:endParaRPr lang="en-US" sz="1400" dirty="0"/>
           </a:p>
@@ -10242,7 +10187,7 @@
                 <a:ea typeface="Calibri" pitchFamily="34" charset="-122"/>
                 <a:cs typeface="Calibri" pitchFamily="34" charset="-120"/>
               </a:rPr>
-              <a:t>Summary numbers for reuse</a:t>
+              <a:t>Manual citation audit still to do</a:t>
             </a:r>
             <a:endParaRPr lang="en-US" sz="1400" dirty="0"/>
           </a:p>
@@ -10356,7 +10301,7 @@
                 <a:ea typeface="Cambria" pitchFamily="34" charset="-122"/>
                 <a:cs typeface="Cambria" pitchFamily="34" charset="-120"/>
               </a:rPr>
-              <a:t>What “done” looks like</a:t>
+              <a:t>Did we reach “done”?</a:t>
             </a:r>
             <a:endParaRPr lang="en-US" sz="3400" dirty="0"/>
           </a:p>
@@ -10417,7 +10362,7 @@
                 <a:ea typeface="Cambria" pitchFamily="34" charset="-122"/>
                 <a:cs typeface="Cambria" pitchFamily="34" charset="-120"/>
               </a:rPr>
-              <a:t>18 × 10 × 6</a:t>
+              <a:t>14 × 10 × 3</a:t>
             </a:r>
             <a:endParaRPr lang="en-US" sz="4400" dirty="0"/>
           </a:p>
@@ -10495,7 +10440,7 @@
                 <a:ea typeface="Calibri" pitchFamily="34" charset="-122"/>
                 <a:cs typeface="Calibri" pitchFamily="34" charset="-120"/>
               </a:rPr>
-              <a:t>about 840 measured runs, all with confidence ranges</a:t>
+              <a:t>full-suite setups; others on subsets: partly met</a:t>
             </a:r>
             <a:endParaRPr lang="en-US" sz="1400" dirty="0"/>
           </a:p>
@@ -10578,7 +10523,7 @@
                 <a:ea typeface="Calibri" pitchFamily="34" charset="-122"/>
                 <a:cs typeface="Calibri" pitchFamily="34" charset="-120"/>
               </a:rPr>
-              <a:t>At least 2 changes proven to help, and at least 1 clear negative result with its cause</a:t>
+              <a:t>2 changes proven to help, 4 negative results with their cause: met</a:t>
             </a:r>
             <a:endParaRPr lang="en-US" sz="1600" dirty="0"/>
           </a:p>
@@ -10661,7 +10606,7 @@
                 <a:ea typeface="Calibri" pitchFamily="34" charset="-122"/>
                 <a:cs typeface="Calibri" pitchFamily="34" charset="-120"/>
               </a:rPr>
-              <a:t>Invented-citation rate measured on 20 or more research questions, with and without the checker</a:t>
+              <a:t>20 research questions: 28% of citations unbacked, 0% after the checker; audit pending</a:t>
             </a:r>
             <a:endParaRPr lang="en-US" sz="1600" dirty="0"/>
           </a:p>
@@ -10744,7 +10689,7 @@
                 <a:ea typeface="Calibri" pitchFamily="34" charset="-122"/>
                 <a:cs typeface="Calibri" pitchFamily="34" charset="-120"/>
               </a:rPr>
-              <a:t>One chart answering: what share of an agent's time is the GPU generating text?</a:t>
+              <a:t>Share of time the GPU works: 12%, decode is 60% of the time: met</a:t>
             </a:r>
             <a:endParaRPr lang="en-US" sz="1600" dirty="0"/>
           </a:p>
@@ -10827,7 +10772,7 @@
                 <a:ea typeface="Calibri" pitchFamily="34" charset="-122"/>
                 <a:cs typeface="Calibri" pitchFamily="34" charset="-120"/>
               </a:rPr>
-              <a:t>Measurement overhead shown to be under 5%</a:t>
+              <a:t>Overhead under 5%: not shown, measured 4% (range 0 to 9%)</a:t>
             </a:r>
             <a:endParaRPr lang="en-US" sz="1600" dirty="0"/>
           </a:p>
@@ -10910,7 +10855,7 @@
                 <a:ea typeface="Calibri" pitchFamily="34" charset="-122"/>
                 <a:cs typeface="Calibri" pitchFamily="34" charset="-120"/>
               </a:rPr>
-              <a:t>Deck, README and summary numbers ready to share</a:t>
+              <a:t>Deck, README and summary numbers: done</a:t>
             </a:r>
             <a:endParaRPr lang="en-US" sz="1600" dirty="0"/>
           </a:p>

</xml_diff>